<commit_message>
Mise à jour rapport
</commit_message>
<xml_diff>
--- a/P8_Realiser_dashboard_et_assurer_veille_technique/soutenance/LAFON_Guillaume_4_presentation_102025.pptx
+++ b/P8_Realiser_dashboard_et_assurer_veille_technique/soutenance/LAFON_Guillaume_4_presentation_102025.pptx
@@ -5,7 +5,7 @@
     <p:sldMasterId id="2147483648" r:id="rId1"/>
   </p:sldMasterIdLst>
   <p:notesMasterIdLst>
-    <p:notesMasterId r:id="rId25"/>
+    <p:notesMasterId r:id="rId27"/>
   </p:notesMasterIdLst>
   <p:sldIdLst>
     <p:sldId id="256" r:id="rId4"/>
@@ -29,6 +29,8 @@
     <p:sldId id="274" r:id="rId22"/>
     <p:sldId id="275" r:id="rId23"/>
     <p:sldId id="276" r:id="rId24"/>
+    <p:sldId id="277" r:id="rId25"/>
+    <p:sldId id="278" r:id="rId26"/>
   </p:sldIdLst>
   <p:sldSz cx="12192000" cy="6858000"/>
   <p:notesSz cx="6858000" cy="9144000"/>
@@ -154,7 +156,7 @@
       </p:grpSpPr>
       <p:sp>
         <p:nvSpPr>
-          <p:cNvPr id="1702833377" name="Header Placeholder 1"/>
+          <p:cNvPr id="2119756984" name="Header Placeholder 1"/>
           <p:cNvSpPr>
             <a:spLocks noGrp="1"/>
           </p:cNvSpPr>
@@ -188,7 +190,7 @@
       </p:sp>
       <p:sp>
         <p:nvSpPr>
-          <p:cNvPr id="890438914" name="Date Placeholder 2"/>
+          <p:cNvPr id="1489142494" name="Date Placeholder 2"/>
           <p:cNvSpPr>
             <a:spLocks noGrp="1"/>
           </p:cNvSpPr>
@@ -226,7 +228,7 @@
       </p:sp>
       <p:sp>
         <p:nvSpPr>
-          <p:cNvPr id="707646307" name="Slide Image Placeholder 3"/>
+          <p:cNvPr id="1973400442" name="Slide Image Placeholder 3"/>
           <p:cNvSpPr>
             <a:spLocks noChangeAspect="1" noGrp="1" noRot="1"/>
           </p:cNvSpPr>
@@ -262,7 +264,7 @@
       </p:sp>
       <p:sp>
         <p:nvSpPr>
-          <p:cNvPr id="1856532042" name="Notes Placeholder 4"/>
+          <p:cNvPr id="2097018484" name="Notes Placeholder 4"/>
           <p:cNvSpPr>
             <a:spLocks noGrp="1"/>
           </p:cNvSpPr>
@@ -336,7 +338,7 @@
       </p:sp>
       <p:sp>
         <p:nvSpPr>
-          <p:cNvPr id="470683787" name="Footer Placeholder 5"/>
+          <p:cNvPr id="1747694589" name="Footer Placeholder 5"/>
           <p:cNvSpPr>
             <a:spLocks noGrp="1"/>
           </p:cNvSpPr>
@@ -370,7 +372,7 @@
       </p:sp>
       <p:sp>
         <p:nvSpPr>
-          <p:cNvPr id="1229622160" name="Slide Number Placeholder 6"/>
+          <p:cNvPr id="1431540801" name="Slide Number Placeholder 6"/>
           <p:cNvSpPr>
             <a:spLocks noGrp="1"/>
           </p:cNvSpPr>
@@ -524,7 +526,7 @@
       </p:grpSpPr>
       <p:sp>
         <p:nvSpPr>
-          <p:cNvPr id="409943078" name="Slide Image Placeholder 1"/>
+          <p:cNvPr id="1725997123" name="Slide Image Placeholder 1"/>
           <p:cNvSpPr>
             <a:spLocks noChangeAspect="1" noGrp="1" noRot="1"/>
           </p:cNvSpPr>
@@ -536,7 +538,7 @@
       </p:sp>
       <p:sp>
         <p:nvSpPr>
-          <p:cNvPr id="1070464334" name="Notes Placeholder 2"/>
+          <p:cNvPr id="1672096638" name="Notes Placeholder 2"/>
           <p:cNvSpPr>
             <a:spLocks noGrp="1"/>
           </p:cNvSpPr>
@@ -558,7 +560,7 @@
       </p:sp>
       <p:sp>
         <p:nvSpPr>
-          <p:cNvPr id="330360765" name="Slide Number Placeholder 3"/>
+          <p:cNvPr id="1199090401" name="Slide Number Placeholder 3"/>
           <p:cNvSpPr>
             <a:spLocks noGrp="1"/>
           </p:cNvSpPr>
@@ -609,7 +611,7 @@
       </p:grpSpPr>
       <p:sp>
         <p:nvSpPr>
-          <p:cNvPr id="366136067" name="Slide Image Placeholder 1"/>
+          <p:cNvPr id="1595481831" name="Slide Image Placeholder 1"/>
           <p:cNvSpPr>
             <a:spLocks noChangeAspect="1" noGrp="1" noRot="1"/>
           </p:cNvSpPr>
@@ -621,7 +623,7 @@
       </p:sp>
       <p:sp>
         <p:nvSpPr>
-          <p:cNvPr id="1470415980" name="Notes Placeholder 2"/>
+          <p:cNvPr id="799537728" name="Notes Placeholder 2"/>
           <p:cNvSpPr>
             <a:spLocks noGrp="1"/>
           </p:cNvSpPr>
@@ -643,7 +645,7 @@
       </p:sp>
       <p:sp>
         <p:nvSpPr>
-          <p:cNvPr id="550335893" name="Slide Number Placeholder 3"/>
+          <p:cNvPr id="1999773263" name="Slide Number Placeholder 3"/>
           <p:cNvSpPr>
             <a:spLocks noGrp="1"/>
           </p:cNvSpPr>
@@ -694,7 +696,7 @@
       </p:grpSpPr>
       <p:sp>
         <p:nvSpPr>
-          <p:cNvPr id="1125406869" name="Slide Image Placeholder 1"/>
+          <p:cNvPr id="740262203" name="Slide Image Placeholder 1"/>
           <p:cNvSpPr>
             <a:spLocks noChangeAspect="1" noGrp="1" noRot="1"/>
           </p:cNvSpPr>
@@ -706,7 +708,7 @@
       </p:sp>
       <p:sp>
         <p:nvSpPr>
-          <p:cNvPr id="537381810" name="Notes Placeholder 2"/>
+          <p:cNvPr id="2073128261" name="Notes Placeholder 2"/>
           <p:cNvSpPr>
             <a:spLocks noGrp="1"/>
           </p:cNvSpPr>
@@ -728,7 +730,7 @@
       </p:sp>
       <p:sp>
         <p:nvSpPr>
-          <p:cNvPr id="2134719102" name="Slide Number Placeholder 3"/>
+          <p:cNvPr id="1174428613" name="Slide Number Placeholder 3"/>
           <p:cNvSpPr>
             <a:spLocks noGrp="1"/>
           </p:cNvSpPr>
@@ -779,7 +781,7 @@
       </p:grpSpPr>
       <p:sp>
         <p:nvSpPr>
-          <p:cNvPr id="754750312" name="Slide Image Placeholder 1"/>
+          <p:cNvPr id="1807279864" name="Slide Image Placeholder 1"/>
           <p:cNvSpPr>
             <a:spLocks noChangeAspect="1" noGrp="1" noRot="1"/>
           </p:cNvSpPr>
@@ -791,7 +793,7 @@
       </p:sp>
       <p:sp>
         <p:nvSpPr>
-          <p:cNvPr id="440652284" name="Notes Placeholder 2"/>
+          <p:cNvPr id="2018278058" name="Notes Placeholder 2"/>
           <p:cNvSpPr>
             <a:spLocks noGrp="1"/>
           </p:cNvSpPr>
@@ -813,7 +815,7 @@
       </p:sp>
       <p:sp>
         <p:nvSpPr>
-          <p:cNvPr id="1826032336" name="Slide Number Placeholder 3"/>
+          <p:cNvPr id="408041023" name="Slide Number Placeholder 3"/>
           <p:cNvSpPr>
             <a:spLocks noGrp="1"/>
           </p:cNvSpPr>
@@ -864,7 +866,7 @@
       </p:grpSpPr>
       <p:sp>
         <p:nvSpPr>
-          <p:cNvPr id="1850400769" name="Slide Image Placeholder 1"/>
+          <p:cNvPr id="1223887183" name="Slide Image Placeholder 1"/>
           <p:cNvSpPr>
             <a:spLocks noChangeAspect="1" noGrp="1" noRot="1"/>
           </p:cNvSpPr>
@@ -876,7 +878,7 @@
       </p:sp>
       <p:sp>
         <p:nvSpPr>
-          <p:cNvPr id="1647047522" name="Notes Placeholder 2"/>
+          <p:cNvPr id="317596838" name="Notes Placeholder 2"/>
           <p:cNvSpPr>
             <a:spLocks noGrp="1"/>
           </p:cNvSpPr>
@@ -898,7 +900,7 @@
       </p:sp>
       <p:sp>
         <p:nvSpPr>
-          <p:cNvPr id="967895264" name="Slide Number Placeholder 3"/>
+          <p:cNvPr id="1303513600" name="Slide Number Placeholder 3"/>
           <p:cNvSpPr>
             <a:spLocks noGrp="1"/>
           </p:cNvSpPr>
@@ -949,7 +951,7 @@
       </p:grpSpPr>
       <p:sp>
         <p:nvSpPr>
-          <p:cNvPr id="272990070" name="Slide Image Placeholder 1"/>
+          <p:cNvPr id="1814683778" name="Slide Image Placeholder 1"/>
           <p:cNvSpPr>
             <a:spLocks noChangeAspect="1" noGrp="1" noRot="1"/>
           </p:cNvSpPr>
@@ -961,7 +963,7 @@
       </p:sp>
       <p:sp>
         <p:nvSpPr>
-          <p:cNvPr id="1808509117" name="Notes Placeholder 2"/>
+          <p:cNvPr id="2112909190" name="Notes Placeholder 2"/>
           <p:cNvSpPr>
             <a:spLocks noGrp="1"/>
           </p:cNvSpPr>
@@ -983,7 +985,7 @@
       </p:sp>
       <p:sp>
         <p:nvSpPr>
-          <p:cNvPr id="966555884" name="Slide Number Placeholder 3"/>
+          <p:cNvPr id="1920380824" name="Slide Number Placeholder 3"/>
           <p:cNvSpPr>
             <a:spLocks noGrp="1"/>
           </p:cNvSpPr>
@@ -1034,7 +1036,7 @@
       </p:grpSpPr>
       <p:sp>
         <p:nvSpPr>
-          <p:cNvPr id="961282856" name="Slide Image Placeholder 1"/>
+          <p:cNvPr id="1547450889" name="Slide Image Placeholder 1"/>
           <p:cNvSpPr>
             <a:spLocks noChangeAspect="1" noGrp="1" noRot="1"/>
           </p:cNvSpPr>
@@ -1046,7 +1048,7 @@
       </p:sp>
       <p:sp>
         <p:nvSpPr>
-          <p:cNvPr id="1470334504" name="Notes Placeholder 2"/>
+          <p:cNvPr id="995506792" name="Notes Placeholder 2"/>
           <p:cNvSpPr>
             <a:spLocks noGrp="1"/>
           </p:cNvSpPr>
@@ -1068,7 +1070,7 @@
       </p:sp>
       <p:sp>
         <p:nvSpPr>
-          <p:cNvPr id="1148028239" name="Slide Number Placeholder 3"/>
+          <p:cNvPr id="1135360935" name="Slide Number Placeholder 3"/>
           <p:cNvSpPr>
             <a:spLocks noGrp="1"/>
           </p:cNvSpPr>
@@ -1119,7 +1121,7 @@
       </p:grpSpPr>
       <p:sp>
         <p:nvSpPr>
-          <p:cNvPr id="985006339" name="Slide Image Placeholder 1"/>
+          <p:cNvPr id="118174239" name="Slide Image Placeholder 1"/>
           <p:cNvSpPr>
             <a:spLocks noChangeAspect="1" noGrp="1" noRot="1"/>
           </p:cNvSpPr>
@@ -1131,7 +1133,7 @@
       </p:sp>
       <p:sp>
         <p:nvSpPr>
-          <p:cNvPr id="1208151687" name="Notes Placeholder 2"/>
+          <p:cNvPr id="2012459974" name="Notes Placeholder 2"/>
           <p:cNvSpPr>
             <a:spLocks noGrp="1"/>
           </p:cNvSpPr>
@@ -1153,7 +1155,7 @@
       </p:sp>
       <p:sp>
         <p:nvSpPr>
-          <p:cNvPr id="1973536179" name="Slide Number Placeholder 3"/>
+          <p:cNvPr id="1185474101" name="Slide Number Placeholder 3"/>
           <p:cNvSpPr>
             <a:spLocks noGrp="1"/>
           </p:cNvSpPr>
@@ -1204,7 +1206,7 @@
       </p:grpSpPr>
       <p:sp>
         <p:nvSpPr>
-          <p:cNvPr id="840214527" name="Slide Image Placeholder 1"/>
+          <p:cNvPr id="1437400583" name="Slide Image Placeholder 1"/>
           <p:cNvSpPr>
             <a:spLocks noChangeAspect="1" noGrp="1" noRot="1"/>
           </p:cNvSpPr>
@@ -1216,7 +1218,7 @@
       </p:sp>
       <p:sp>
         <p:nvSpPr>
-          <p:cNvPr id="1369760691" name="Notes Placeholder 2"/>
+          <p:cNvPr id="34604388" name="Notes Placeholder 2"/>
           <p:cNvSpPr>
             <a:spLocks noGrp="1"/>
           </p:cNvSpPr>
@@ -1238,7 +1240,7 @@
       </p:sp>
       <p:sp>
         <p:nvSpPr>
-          <p:cNvPr id="1102511553" name="Slide Number Placeholder 3"/>
+          <p:cNvPr id="1472763104" name="Slide Number Placeholder 3"/>
           <p:cNvSpPr>
             <a:spLocks noGrp="1"/>
           </p:cNvSpPr>
@@ -1289,7 +1291,7 @@
       </p:grpSpPr>
       <p:sp>
         <p:nvSpPr>
-          <p:cNvPr id="317081025" name="Slide Image Placeholder 1"/>
+          <p:cNvPr id="1086431613" name="Slide Image Placeholder 1"/>
           <p:cNvSpPr>
             <a:spLocks noChangeAspect="1" noGrp="1" noRot="1"/>
           </p:cNvSpPr>
@@ -1301,7 +1303,7 @@
       </p:sp>
       <p:sp>
         <p:nvSpPr>
-          <p:cNvPr id="176906810" name="Notes Placeholder 2"/>
+          <p:cNvPr id="1882052303" name="Notes Placeholder 2"/>
           <p:cNvSpPr>
             <a:spLocks noGrp="1"/>
           </p:cNvSpPr>
@@ -1323,7 +1325,7 @@
       </p:sp>
       <p:sp>
         <p:nvSpPr>
-          <p:cNvPr id="1889220933" name="Slide Number Placeholder 3"/>
+          <p:cNvPr id="2133492721" name="Slide Number Placeholder 3"/>
           <p:cNvSpPr>
             <a:spLocks noGrp="1"/>
           </p:cNvSpPr>
@@ -1374,7 +1376,7 @@
       </p:grpSpPr>
       <p:sp>
         <p:nvSpPr>
-          <p:cNvPr id="350800791" name="Slide Image Placeholder 1"/>
+          <p:cNvPr id="657069490" name="Slide Image Placeholder 1"/>
           <p:cNvSpPr>
             <a:spLocks noChangeAspect="1" noGrp="1" noRot="1"/>
           </p:cNvSpPr>
@@ -1386,7 +1388,7 @@
       </p:sp>
       <p:sp>
         <p:nvSpPr>
-          <p:cNvPr id="1368450249" name="Notes Placeholder 2"/>
+          <p:cNvPr id="1948386540" name="Notes Placeholder 2"/>
           <p:cNvSpPr>
             <a:spLocks noGrp="1"/>
           </p:cNvSpPr>
@@ -1408,7 +1410,7 @@
       </p:sp>
       <p:sp>
         <p:nvSpPr>
-          <p:cNvPr id="1827389515" name="Slide Number Placeholder 3"/>
+          <p:cNvPr id="1334803597" name="Slide Number Placeholder 3"/>
           <p:cNvSpPr>
             <a:spLocks noGrp="1"/>
           </p:cNvSpPr>
@@ -1424,7 +1426,7 @@
             <a:pPr>
               <a:defRPr/>
             </a:pPr>
-            <a:fld id="{E6E2E6D0-8CBC-C039-4057-68DBCA719AA2}" type="slidenum">
+            <a:fld id="{8E6E3986-6DF1-12DF-ADDD-E8BFA8E4EFB0}" type="slidenum">
               <a:rPr/>
               <a:t/>
             </a:fld>
@@ -1459,7 +1461,7 @@
       </p:grpSpPr>
       <p:sp>
         <p:nvSpPr>
-          <p:cNvPr id="1646574058" name="Slide Image Placeholder 1"/>
+          <p:cNvPr id="271587897" name="Slide Image Placeholder 1"/>
           <p:cNvSpPr>
             <a:spLocks noChangeAspect="1" noGrp="1" noRot="1"/>
           </p:cNvSpPr>
@@ -1471,7 +1473,7 @@
       </p:sp>
       <p:sp>
         <p:nvSpPr>
-          <p:cNvPr id="322954496" name="Notes Placeholder 2"/>
+          <p:cNvPr id="1942113237" name="Notes Placeholder 2"/>
           <p:cNvSpPr>
             <a:spLocks noGrp="1"/>
           </p:cNvSpPr>
@@ -1493,7 +1495,7 @@
       </p:sp>
       <p:sp>
         <p:nvSpPr>
-          <p:cNvPr id="1518423659" name="Slide Number Placeholder 3"/>
+          <p:cNvPr id="1191139168" name="Slide Number Placeholder 3"/>
           <p:cNvSpPr>
             <a:spLocks noGrp="1"/>
           </p:cNvSpPr>
@@ -1544,7 +1546,7 @@
       </p:grpSpPr>
       <p:sp>
         <p:nvSpPr>
-          <p:cNvPr id="608938016" name="Slide Image Placeholder 1"/>
+          <p:cNvPr id="1799945744" name="Slide Image Placeholder 1"/>
           <p:cNvSpPr>
             <a:spLocks noChangeAspect="1" noGrp="1" noRot="1"/>
           </p:cNvSpPr>
@@ -1556,7 +1558,7 @@
       </p:sp>
       <p:sp>
         <p:nvSpPr>
-          <p:cNvPr id="790768998" name="Notes Placeholder 2"/>
+          <p:cNvPr id="1734493432" name="Notes Placeholder 2"/>
           <p:cNvSpPr>
             <a:spLocks noGrp="1"/>
           </p:cNvSpPr>
@@ -1578,7 +1580,7 @@
       </p:sp>
       <p:sp>
         <p:nvSpPr>
-          <p:cNvPr id="1635629011" name="Slide Number Placeholder 3"/>
+          <p:cNvPr id="1717000016" name="Slide Number Placeholder 3"/>
           <p:cNvSpPr>
             <a:spLocks noGrp="1"/>
           </p:cNvSpPr>
@@ -1594,7 +1596,7 @@
             <a:pPr>
               <a:defRPr/>
             </a:pPr>
-            <a:fld id="{BB2CF20C-FB87-D9D1-76CB-B37E7F57C980}" type="slidenum">
+            <a:fld id="{A5FBBB01-7E4C-7355-094B-10B9579BA455}" type="slidenum">
               <a:rPr/>
               <a:t/>
             </a:fld>
@@ -1629,7 +1631,7 @@
       </p:grpSpPr>
       <p:sp>
         <p:nvSpPr>
-          <p:cNvPr id="10519376" name="Slide Image Placeholder 1"/>
+          <p:cNvPr id="1133721884" name="Slide Image Placeholder 1"/>
           <p:cNvSpPr>
             <a:spLocks noChangeAspect="1" noGrp="1" noRot="1"/>
           </p:cNvSpPr>
@@ -1641,7 +1643,7 @@
       </p:sp>
       <p:sp>
         <p:nvSpPr>
-          <p:cNvPr id="933989597" name="Notes Placeholder 2"/>
+          <p:cNvPr id="1776354656" name="Notes Placeholder 2"/>
           <p:cNvSpPr>
             <a:spLocks noGrp="1"/>
           </p:cNvSpPr>
@@ -1663,7 +1665,177 @@
       </p:sp>
       <p:sp>
         <p:nvSpPr>
-          <p:cNvPr id="1329684810" name="Slide Number Placeholder 3"/>
+          <p:cNvPr id="1872355321" name="Slide Number Placeholder 3"/>
+          <p:cNvSpPr>
+            <a:spLocks noGrp="1"/>
+          </p:cNvSpPr>
+          <p:nvPr>
+            <p:ph type="sldNum" sz="quarter" idx="10"/>
+          </p:nvPr>
+        </p:nvSpPr>
+        <p:spPr bwMode="auto"/>
+        <p:txBody>
+          <a:bodyPr/>
+          <a:lstStyle/>
+          <a:p>
+            <a:pPr>
+              <a:defRPr/>
+            </a:pPr>
+            <a:fld id="{E6E2E6D0-8CBC-C039-4057-68DBCA719AA2}" type="slidenum">
+              <a:rPr/>
+              <a:t/>
+            </a:fld>
+            <a:endParaRPr/>
+          </a:p>
+        </p:txBody>
+      </p:sp>
+    </p:spTree>
+  </p:cSld>
+  <p:clrMapOvr>
+    <a:masterClrMapping/>
+  </p:clrMapOvr>
+</p:notes>
+</file>
+
+<file path=ppt/notesSlides/notesSlide22.xml><?xml version="1.0" encoding="utf-8"?>
+<p:notes xmlns:a="http://schemas.openxmlformats.org/drawingml/2006/main" xmlns:r="http://schemas.openxmlformats.org/officeDocument/2006/relationships" xmlns:p="http://schemas.openxmlformats.org/presentationml/2006/main" xmlns:m="http://schemas.openxmlformats.org/officeDocument/2006/math" xmlns:w="http://schemas.openxmlformats.org/wordprocessingml/2006/main">
+  <p:cSld name="">
+    <p:spTree>
+      <p:nvGrpSpPr>
+        <p:cNvPr id="1" name=""/>
+        <p:cNvGrpSpPr/>
+        <p:nvPr/>
+      </p:nvGrpSpPr>
+      <p:grpSpPr bwMode="auto">
+        <a:xfrm>
+          <a:off x="0" y="0"/>
+          <a:ext cx="0" cy="0"/>
+          <a:chOff x="0" y="0"/>
+          <a:chExt cx="0" cy="0"/>
+        </a:xfrm>
+      </p:grpSpPr>
+      <p:sp>
+        <p:nvSpPr>
+          <p:cNvPr id="1890673619" name="Slide Image Placeholder 1"/>
+          <p:cNvSpPr>
+            <a:spLocks noChangeAspect="1" noGrp="1" noRot="1"/>
+          </p:cNvSpPr>
+          <p:nvPr>
+            <p:ph type="sldImg"/>
+          </p:nvPr>
+        </p:nvSpPr>
+        <p:spPr bwMode="auto"/>
+      </p:sp>
+      <p:sp>
+        <p:nvSpPr>
+          <p:cNvPr id="2022454009" name="Notes Placeholder 2"/>
+          <p:cNvSpPr>
+            <a:spLocks noGrp="1"/>
+          </p:cNvSpPr>
+          <p:nvPr>
+            <p:ph type="body" idx="1"/>
+          </p:nvPr>
+        </p:nvSpPr>
+        <p:spPr bwMode="auto"/>
+        <p:txBody>
+          <a:bodyPr/>
+          <a:lstStyle/>
+          <a:p>
+            <a:pPr>
+              <a:defRPr/>
+            </a:pPr>
+            <a:endParaRPr/>
+          </a:p>
+        </p:txBody>
+      </p:sp>
+      <p:sp>
+        <p:nvSpPr>
+          <p:cNvPr id="12261508" name="Slide Number Placeholder 3"/>
+          <p:cNvSpPr>
+            <a:spLocks noGrp="1"/>
+          </p:cNvSpPr>
+          <p:nvPr>
+            <p:ph type="sldNum" sz="quarter" idx="10"/>
+          </p:nvPr>
+        </p:nvSpPr>
+        <p:spPr bwMode="auto"/>
+        <p:txBody>
+          <a:bodyPr/>
+          <a:lstStyle/>
+          <a:p>
+            <a:pPr>
+              <a:defRPr/>
+            </a:pPr>
+            <a:fld id="{BB2CF20C-FB87-D9D1-76CB-B37E7F57C980}" type="slidenum">
+              <a:rPr/>
+              <a:t/>
+            </a:fld>
+            <a:endParaRPr/>
+          </a:p>
+        </p:txBody>
+      </p:sp>
+    </p:spTree>
+  </p:cSld>
+  <p:clrMapOvr>
+    <a:masterClrMapping/>
+  </p:clrMapOvr>
+</p:notes>
+</file>
+
+<file path=ppt/notesSlides/notesSlide23.xml><?xml version="1.0" encoding="utf-8"?>
+<p:notes xmlns:a="http://schemas.openxmlformats.org/drawingml/2006/main" xmlns:r="http://schemas.openxmlformats.org/officeDocument/2006/relationships" xmlns:p="http://schemas.openxmlformats.org/presentationml/2006/main" xmlns:m="http://schemas.openxmlformats.org/officeDocument/2006/math" xmlns:w="http://schemas.openxmlformats.org/wordprocessingml/2006/main">
+  <p:cSld name="">
+    <p:spTree>
+      <p:nvGrpSpPr>
+        <p:cNvPr id="1" name=""/>
+        <p:cNvGrpSpPr/>
+        <p:nvPr/>
+      </p:nvGrpSpPr>
+      <p:grpSpPr bwMode="auto">
+        <a:xfrm>
+          <a:off x="0" y="0"/>
+          <a:ext cx="0" cy="0"/>
+          <a:chOff x="0" y="0"/>
+          <a:chExt cx="0" cy="0"/>
+        </a:xfrm>
+      </p:grpSpPr>
+      <p:sp>
+        <p:nvSpPr>
+          <p:cNvPr id="1573799374" name="Slide Image Placeholder 1"/>
+          <p:cNvSpPr>
+            <a:spLocks noChangeAspect="1" noGrp="1" noRot="1"/>
+          </p:cNvSpPr>
+          <p:nvPr>
+            <p:ph type="sldImg"/>
+          </p:nvPr>
+        </p:nvSpPr>
+        <p:spPr bwMode="auto"/>
+      </p:sp>
+      <p:sp>
+        <p:nvSpPr>
+          <p:cNvPr id="1346100258" name="Notes Placeholder 2"/>
+          <p:cNvSpPr>
+            <a:spLocks noGrp="1"/>
+          </p:cNvSpPr>
+          <p:nvPr>
+            <p:ph type="body" idx="1"/>
+          </p:nvPr>
+        </p:nvSpPr>
+        <p:spPr bwMode="auto"/>
+        <p:txBody>
+          <a:bodyPr/>
+          <a:lstStyle/>
+          <a:p>
+            <a:pPr>
+              <a:defRPr/>
+            </a:pPr>
+            <a:endParaRPr/>
+          </a:p>
+        </p:txBody>
+      </p:sp>
+      <p:sp>
+        <p:nvSpPr>
+          <p:cNvPr id="595223571" name="Slide Number Placeholder 3"/>
           <p:cNvSpPr>
             <a:spLocks noGrp="1"/>
           </p:cNvSpPr>
@@ -1714,7 +1886,7 @@
       </p:grpSpPr>
       <p:sp>
         <p:nvSpPr>
-          <p:cNvPr id="1481197099" name="Slide Image Placeholder 1"/>
+          <p:cNvPr id="145571545" name="Slide Image Placeholder 1"/>
           <p:cNvSpPr>
             <a:spLocks noChangeAspect="1" noGrp="1" noRot="1"/>
           </p:cNvSpPr>
@@ -1726,7 +1898,7 @@
       </p:sp>
       <p:sp>
         <p:nvSpPr>
-          <p:cNvPr id="281242213" name="Notes Placeholder 2"/>
+          <p:cNvPr id="1543423306" name="Notes Placeholder 2"/>
           <p:cNvSpPr>
             <a:spLocks noGrp="1"/>
           </p:cNvSpPr>
@@ -1748,7 +1920,7 @@
       </p:sp>
       <p:sp>
         <p:nvSpPr>
-          <p:cNvPr id="333640219" name="Slide Number Placeholder 3"/>
+          <p:cNvPr id="675741524" name="Slide Number Placeholder 3"/>
           <p:cNvSpPr>
             <a:spLocks noGrp="1"/>
           </p:cNvSpPr>
@@ -1799,7 +1971,7 @@
       </p:grpSpPr>
       <p:sp>
         <p:nvSpPr>
-          <p:cNvPr id="721495516" name="Slide Image Placeholder 1"/>
+          <p:cNvPr id="854434650" name="Slide Image Placeholder 1"/>
           <p:cNvSpPr>
             <a:spLocks noChangeAspect="1" noGrp="1" noRot="1"/>
           </p:cNvSpPr>
@@ -1811,7 +1983,7 @@
       </p:sp>
       <p:sp>
         <p:nvSpPr>
-          <p:cNvPr id="1468064090" name="Notes Placeholder 2"/>
+          <p:cNvPr id="259852013" name="Notes Placeholder 2"/>
           <p:cNvSpPr>
             <a:spLocks noGrp="1"/>
           </p:cNvSpPr>
@@ -1833,7 +2005,7 @@
       </p:sp>
       <p:sp>
         <p:nvSpPr>
-          <p:cNvPr id="471008794" name="Slide Number Placeholder 3"/>
+          <p:cNvPr id="1910635615" name="Slide Number Placeholder 3"/>
           <p:cNvSpPr>
             <a:spLocks noGrp="1"/>
           </p:cNvSpPr>
@@ -1884,7 +2056,7 @@
       </p:grpSpPr>
       <p:sp>
         <p:nvSpPr>
-          <p:cNvPr id="1179548752" name="Slide Image Placeholder 1"/>
+          <p:cNvPr id="767990715" name="Slide Image Placeholder 1"/>
           <p:cNvSpPr>
             <a:spLocks noChangeAspect="1" noGrp="1" noRot="1"/>
           </p:cNvSpPr>
@@ -1896,7 +2068,7 @@
       </p:sp>
       <p:sp>
         <p:nvSpPr>
-          <p:cNvPr id="858525347" name="Notes Placeholder 2"/>
+          <p:cNvPr id="252342362" name="Notes Placeholder 2"/>
           <p:cNvSpPr>
             <a:spLocks noGrp="1"/>
           </p:cNvSpPr>
@@ -1918,7 +2090,7 @@
       </p:sp>
       <p:sp>
         <p:nvSpPr>
-          <p:cNvPr id="935651145" name="Slide Number Placeholder 3"/>
+          <p:cNvPr id="65364156" name="Slide Number Placeholder 3"/>
           <p:cNvSpPr>
             <a:spLocks noGrp="1"/>
           </p:cNvSpPr>
@@ -1969,7 +2141,7 @@
       </p:grpSpPr>
       <p:sp>
         <p:nvSpPr>
-          <p:cNvPr id="224450063" name="Slide Image Placeholder 1"/>
+          <p:cNvPr id="618677422" name="Slide Image Placeholder 1"/>
           <p:cNvSpPr>
             <a:spLocks noChangeAspect="1" noGrp="1" noRot="1"/>
           </p:cNvSpPr>
@@ -1981,7 +2153,7 @@
       </p:sp>
       <p:sp>
         <p:nvSpPr>
-          <p:cNvPr id="1334080946" name="Notes Placeholder 2"/>
+          <p:cNvPr id="1917406793" name="Notes Placeholder 2"/>
           <p:cNvSpPr>
             <a:spLocks noGrp="1"/>
           </p:cNvSpPr>
@@ -2122,7 +2294,7 @@
       </p:sp>
       <p:sp>
         <p:nvSpPr>
-          <p:cNvPr id="1319978689" name="Slide Number Placeholder 3"/>
+          <p:cNvPr id="613893779" name="Slide Number Placeholder 3"/>
           <p:cNvSpPr>
             <a:spLocks noGrp="1"/>
           </p:cNvSpPr>
@@ -2173,7 +2345,7 @@
       </p:grpSpPr>
       <p:sp>
         <p:nvSpPr>
-          <p:cNvPr id="427670948" name="Slide Image Placeholder 1"/>
+          <p:cNvPr id="1062393264" name="Slide Image Placeholder 1"/>
           <p:cNvSpPr>
             <a:spLocks noChangeAspect="1" noGrp="1" noRot="1"/>
           </p:cNvSpPr>
@@ -2185,7 +2357,7 @@
       </p:sp>
       <p:sp>
         <p:nvSpPr>
-          <p:cNvPr id="1770525420" name="Notes Placeholder 2"/>
+          <p:cNvPr id="124046993" name="Notes Placeholder 2"/>
           <p:cNvSpPr>
             <a:spLocks noGrp="1"/>
           </p:cNvSpPr>
@@ -2207,7 +2379,7 @@
       </p:sp>
       <p:sp>
         <p:nvSpPr>
-          <p:cNvPr id="1808204472" name="Slide Number Placeholder 3"/>
+          <p:cNvPr id="362308141" name="Slide Number Placeholder 3"/>
           <p:cNvSpPr>
             <a:spLocks noGrp="1"/>
           </p:cNvSpPr>
@@ -2258,7 +2430,7 @@
       </p:grpSpPr>
       <p:sp>
         <p:nvSpPr>
-          <p:cNvPr id="1362506438" name="Slide Image Placeholder 1"/>
+          <p:cNvPr id="1044848514" name="Slide Image Placeholder 1"/>
           <p:cNvSpPr>
             <a:spLocks noChangeAspect="1" noGrp="1" noRot="1"/>
           </p:cNvSpPr>
@@ -2270,7 +2442,7 @@
       </p:sp>
       <p:sp>
         <p:nvSpPr>
-          <p:cNvPr id="589703670" name="Notes Placeholder 2"/>
+          <p:cNvPr id="224764488" name="Notes Placeholder 2"/>
           <p:cNvSpPr>
             <a:spLocks noGrp="1"/>
           </p:cNvSpPr>
@@ -2292,7 +2464,7 @@
       </p:sp>
       <p:sp>
         <p:nvSpPr>
-          <p:cNvPr id="1280150515" name="Slide Number Placeholder 3"/>
+          <p:cNvPr id="669164557" name="Slide Number Placeholder 3"/>
           <p:cNvSpPr>
             <a:spLocks noGrp="1"/>
           </p:cNvSpPr>
@@ -2343,7 +2515,7 @@
       </p:grpSpPr>
       <p:sp>
         <p:nvSpPr>
-          <p:cNvPr id="268865325" name="Slide Image Placeholder 1"/>
+          <p:cNvPr id="223290431" name="Slide Image Placeholder 1"/>
           <p:cNvSpPr>
             <a:spLocks noChangeAspect="1" noGrp="1" noRot="1"/>
           </p:cNvSpPr>
@@ -2355,7 +2527,7 @@
       </p:sp>
       <p:sp>
         <p:nvSpPr>
-          <p:cNvPr id="271275009" name="Notes Placeholder 2"/>
+          <p:cNvPr id="808764694" name="Notes Placeholder 2"/>
           <p:cNvSpPr>
             <a:spLocks noGrp="1"/>
           </p:cNvSpPr>
@@ -2377,7 +2549,7 @@
       </p:sp>
       <p:sp>
         <p:nvSpPr>
-          <p:cNvPr id="334189465" name="Slide Number Placeholder 3"/>
+          <p:cNvPr id="1137636907" name="Slide Number Placeholder 3"/>
           <p:cNvSpPr>
             <a:spLocks noGrp="1"/>
           </p:cNvSpPr>
@@ -2428,7 +2600,7 @@
       </p:grpSpPr>
       <p:sp>
         <p:nvSpPr>
-          <p:cNvPr id="206692440" name="Title 1"/>
+          <p:cNvPr id="124468186" name="Title 1"/>
           <p:cNvSpPr>
             <a:spLocks noGrp="1"/>
           </p:cNvSpPr>
@@ -2463,7 +2635,7 @@
       </p:sp>
       <p:sp>
         <p:nvSpPr>
-          <p:cNvPr id="1978573307" name="Subtitle 2"/>
+          <p:cNvPr id="2102140043" name="Subtitle 2"/>
           <p:cNvSpPr>
             <a:spLocks noGrp="1"/>
           </p:cNvSpPr>
@@ -2531,7 +2703,7 @@
       </p:sp>
       <p:sp>
         <p:nvSpPr>
-          <p:cNvPr id="464561067" name="Espace réservé du numéro de diapositive 5"/>
+          <p:cNvPr id="1984296468" name="Espace réservé du numéro de diapositive 5"/>
           <p:cNvSpPr>
             <a:spLocks noGrp="1"/>
           </p:cNvSpPr>
@@ -2654,7 +2826,7 @@
       </p:grpSpPr>
       <p:sp>
         <p:nvSpPr>
-          <p:cNvPr id="802382899" name="Title 1"/>
+          <p:cNvPr id="1170333836" name="Title 1"/>
           <p:cNvSpPr>
             <a:spLocks noGrp="1"/>
           </p:cNvSpPr>
@@ -2685,7 +2857,7 @@
       </p:sp>
       <p:sp>
         <p:nvSpPr>
-          <p:cNvPr id="790516725" name="Content Placeholder 2"/>
+          <p:cNvPr id="309424796" name="Content Placeholder 2"/>
           <p:cNvSpPr>
             <a:spLocks noGrp="1"/>
           </p:cNvSpPr>
@@ -2756,7 +2928,7 @@
       </p:sp>
       <p:sp>
         <p:nvSpPr>
-          <p:cNvPr id="1445738978" name="Espace réservé du numéro de diapositive 5"/>
+          <p:cNvPr id="260359838" name="Espace réservé du numéro de diapositive 5"/>
           <p:cNvSpPr>
             <a:spLocks noGrp="1"/>
           </p:cNvSpPr>
@@ -2879,7 +3051,7 @@
       </p:grpSpPr>
       <p:sp>
         <p:nvSpPr>
-          <p:cNvPr id="867712113" name="Title 1"/>
+          <p:cNvPr id="1922872001" name="Title 1"/>
           <p:cNvSpPr>
             <a:spLocks noGrp="1"/>
           </p:cNvSpPr>
@@ -2914,7 +3086,7 @@
       </p:sp>
       <p:sp>
         <p:nvSpPr>
-          <p:cNvPr id="1871214040" name="Text Placeholder 2"/>
+          <p:cNvPr id="39530355" name="Text Placeholder 2"/>
           <p:cNvSpPr>
             <a:spLocks noGrp="1"/>
           </p:cNvSpPr>
@@ -3036,7 +3208,7 @@
       </p:sp>
       <p:sp>
         <p:nvSpPr>
-          <p:cNvPr id="100307055" name="Espace réservé du numéro de diapositive 5"/>
+          <p:cNvPr id="2066349320" name="Espace réservé du numéro de diapositive 5"/>
           <p:cNvSpPr>
             <a:spLocks noGrp="1"/>
           </p:cNvSpPr>
@@ -3159,7 +3331,7 @@
       </p:grpSpPr>
       <p:sp>
         <p:nvSpPr>
-          <p:cNvPr id="396773428" name="Title 1"/>
+          <p:cNvPr id="1738514395" name="Title 1"/>
           <p:cNvSpPr>
             <a:spLocks noGrp="1"/>
           </p:cNvSpPr>
@@ -3190,7 +3362,7 @@
       </p:sp>
       <p:sp>
         <p:nvSpPr>
-          <p:cNvPr id="2090255136" name="Content Placeholder 2"/>
+          <p:cNvPr id="1213309371" name="Content Placeholder 2"/>
           <p:cNvSpPr>
             <a:spLocks noGrp="1"/>
           </p:cNvSpPr>
@@ -3261,7 +3433,7 @@
       </p:sp>
       <p:sp>
         <p:nvSpPr>
-          <p:cNvPr id="30758213" name="Content Placeholder 3"/>
+          <p:cNvPr id="105474443" name="Content Placeholder 3"/>
           <p:cNvSpPr>
             <a:spLocks noGrp="1"/>
           </p:cNvSpPr>
@@ -3332,7 +3504,7 @@
       </p:sp>
       <p:sp>
         <p:nvSpPr>
-          <p:cNvPr id="90592012" name="Espace réservé du numéro de diapositive 5"/>
+          <p:cNvPr id="1719637465" name="Espace réservé du numéro de diapositive 5"/>
           <p:cNvSpPr>
             <a:spLocks noGrp="1"/>
           </p:cNvSpPr>
@@ -3462,13 +3634,13 @@
       </p:grpSpPr>
       <p:pic>
         <p:nvPicPr>
-          <p:cNvPr id="1282014473" name="Picture 4"/>
+          <p:cNvPr id="5943388" name="Picture 4"/>
           <p:cNvPicPr>
             <a:picLocks noChangeAspect="1"/>
           </p:cNvPicPr>
           <p:nvPr userDrawn="1"/>
         </p:nvPicPr>
-        <p:blipFill>
+        <p:blipFill rotWithShape="1">
           <a:blip r:embed="rId6"/>
           <a:stretch/>
         </p:blipFill>
@@ -3484,7 +3656,7 @@
       </p:pic>
       <p:sp>
         <p:nvSpPr>
-          <p:cNvPr id="949205299" name="Title Placeholder 1"/>
+          <p:cNvPr id="1044890581" name="Title Placeholder 1"/>
           <p:cNvSpPr>
             <a:spLocks noGrp="1"/>
           </p:cNvSpPr>
@@ -3528,7 +3700,7 @@
       </p:sp>
       <p:sp>
         <p:nvSpPr>
-          <p:cNvPr id="264031861" name="Text Placeholder 2"/>
+          <p:cNvPr id="321722848" name="Text Placeholder 2"/>
           <p:cNvSpPr>
             <a:spLocks noGrp="1"/>
           </p:cNvSpPr>
@@ -3652,7 +3824,7 @@
       </p:sp>
       <p:sp>
         <p:nvSpPr>
-          <p:cNvPr id="252531086" name="Espace réservé du numéro de diapositive 5"/>
+          <p:cNvPr id="901035211" name="Espace réservé du numéro de diapositive 5"/>
           <p:cNvSpPr>
             <a:spLocks noGrp="1"/>
           </p:cNvSpPr>
@@ -4060,7 +4232,7 @@
       </p:grpSpPr>
       <p:sp>
         <p:nvSpPr>
-          <p:cNvPr id="1434043869" name="Title 1"/>
+          <p:cNvPr id="548722414" name="Title 1"/>
           <p:cNvSpPr>
             <a:spLocks noGrp="1"/>
           </p:cNvSpPr>
@@ -4086,7 +4258,7 @@
       </p:sp>
       <p:sp>
         <p:nvSpPr>
-          <p:cNvPr id="1666463267" name="Subtitle 2"/>
+          <p:cNvPr id="1217537102" name="Subtitle 2"/>
           <p:cNvSpPr>
             <a:spLocks noGrp="1"/>
           </p:cNvSpPr>
@@ -4179,7 +4351,7 @@
       </p:grpSpPr>
       <p:sp>
         <p:nvSpPr>
-          <p:cNvPr id="398419078" name="Title 1"/>
+          <p:cNvPr id="1560299286" name="Title 1"/>
           <p:cNvSpPr>
             <a:spLocks noGrp="1"/>
           </p:cNvSpPr>
@@ -4222,7 +4394,7 @@
       </p:sp>
       <p:sp>
         <p:nvSpPr>
-          <p:cNvPr id="978528722" name="Espace réservé du numéro de diapositive 5"/>
+          <p:cNvPr id="826260602" name="Espace réservé du numéro de diapositive 5"/>
           <p:cNvSpPr>
             <a:spLocks noGrp="1"/>
           </p:cNvSpPr>
@@ -4320,7 +4492,7 @@
       </p:sp>
       <p:sp>
         <p:nvSpPr>
-          <p:cNvPr id="676829455" name="Content Placeholder 2"/>
+          <p:cNvPr id="1110490372" name="Content Placeholder 2"/>
           <p:cNvSpPr>
             <a:spLocks noGrp="1"/>
           </p:cNvSpPr>
@@ -4369,13 +4541,13 @@
       </p:sp>
       <p:pic>
         <p:nvPicPr>
-          <p:cNvPr id="795195504" name=""/>
+          <p:cNvPr id="684201515" name=""/>
           <p:cNvPicPr>
             <a:picLocks noChangeAspect="1"/>
           </p:cNvPicPr>
           <p:nvPr/>
         </p:nvPicPr>
-        <p:blipFill>
+        <p:blipFill rotWithShape="1">
           <a:blip r:embed="rId3"/>
           <a:stretch/>
         </p:blipFill>
@@ -4391,7 +4563,7 @@
       </p:pic>
       <p:sp>
         <p:nvSpPr>
-          <p:cNvPr id="610194631" name="Content Placeholder 2"/>
+          <p:cNvPr id="1171690423" name="Content Placeholder 2"/>
           <p:cNvSpPr>
             <a:spLocks noGrp="1"/>
           </p:cNvSpPr>
@@ -4474,7 +4646,7 @@
       </p:grpSpPr>
       <p:sp>
         <p:nvSpPr>
-          <p:cNvPr id="387449808" name="Title 1"/>
+          <p:cNvPr id="964658942" name="Title 1"/>
           <p:cNvSpPr>
             <a:spLocks noGrp="1"/>
           </p:cNvSpPr>
@@ -4512,7 +4684,7 @@
       </p:sp>
       <p:sp>
         <p:nvSpPr>
-          <p:cNvPr id="665369361" name="Espace réservé du numéro de diapositive 5"/>
+          <p:cNvPr id="57835145" name="Espace réservé du numéro de diapositive 5"/>
           <p:cNvSpPr>
             <a:spLocks noGrp="1"/>
           </p:cNvSpPr>
@@ -4610,13 +4782,13 @@
       </p:sp>
       <p:pic>
         <p:nvPicPr>
-          <p:cNvPr id="595494430" name=""/>
+          <p:cNvPr id="1278307882" name=""/>
           <p:cNvPicPr>
             <a:picLocks noChangeAspect="1"/>
           </p:cNvPicPr>
           <p:nvPr/>
         </p:nvPicPr>
-        <p:blipFill>
+        <p:blipFill rotWithShape="1">
           <a:blip r:embed="rId3"/>
           <a:stretch/>
         </p:blipFill>
@@ -4665,7 +4837,7 @@
       </p:grpSpPr>
       <p:sp>
         <p:nvSpPr>
-          <p:cNvPr id="565288260" name="Title 1"/>
+          <p:cNvPr id="1790975928" name="Title 1"/>
           <p:cNvSpPr>
             <a:spLocks noGrp="1"/>
           </p:cNvSpPr>
@@ -4715,7 +4887,7 @@
       </p:sp>
       <p:sp>
         <p:nvSpPr>
-          <p:cNvPr id="944689335" name="Espace réservé du numéro de diapositive 5"/>
+          <p:cNvPr id="824338291" name="Espace réservé du numéro de diapositive 5"/>
           <p:cNvSpPr>
             <a:spLocks noGrp="1"/>
           </p:cNvSpPr>
@@ -4813,7 +4985,7 @@
       </p:sp>
       <p:graphicFrame>
         <p:nvGraphicFramePr>
-          <p:cNvPr id="1672343804" name=""/>
+          <p:cNvPr id="579542819" name=""/>
           <p:cNvGraphicFramePr>
             <a:graphicFrameLocks xmlns:a="http://schemas.openxmlformats.org/drawingml/2006/main" noChangeAspect="1"/>
           </p:cNvGraphicFramePr>
@@ -4829,11 +5001,11 @@
               <p:embed/>
               <p:pic>
                 <p:nvPicPr>
-                  <p:cNvPr id="1672343804" name=""/>
+                  <p:cNvPr id="579542819" name=""/>
                   <p:cNvPicPr/>
                   <p:nvPr/>
                 </p:nvPicPr>
-                <p:blipFill>
+                <p:blipFill rotWithShape="1">
                   <a:blip r:embed="rId3"/>
                   <a:stretch/>
                 </p:blipFill>
@@ -4853,13 +5025,13 @@
       </p:graphicFrame>
       <p:pic>
         <p:nvPicPr>
-          <p:cNvPr id="929231377" name=""/>
+          <p:cNvPr id="307004139" name=""/>
           <p:cNvPicPr>
             <a:picLocks noChangeAspect="1"/>
           </p:cNvPicPr>
           <p:nvPr/>
         </p:nvPicPr>
-        <p:blipFill>
+        <p:blipFill rotWithShape="1">
           <a:blip r:embed="rId5"/>
           <a:stretch/>
         </p:blipFill>
@@ -4909,7 +5081,7 @@
       </p:grpSpPr>
       <p:sp>
         <p:nvSpPr>
-          <p:cNvPr id="811140694" name="Title 1"/>
+          <p:cNvPr id="1912435967" name="Title 1"/>
           <p:cNvSpPr>
             <a:spLocks noGrp="1"/>
           </p:cNvSpPr>
@@ -4952,7 +5124,7 @@
       </p:sp>
       <p:sp>
         <p:nvSpPr>
-          <p:cNvPr id="1967887749" name="Espace réservé du numéro de diapositive 5"/>
+          <p:cNvPr id="620062590" name="Espace réservé du numéro de diapositive 5"/>
           <p:cNvSpPr>
             <a:spLocks noGrp="1"/>
           </p:cNvSpPr>
@@ -5050,7 +5222,7 @@
       </p:sp>
       <p:graphicFrame>
         <p:nvGraphicFramePr>
-          <p:cNvPr id="2055838269" name=""/>
+          <p:cNvPr id="1575510896" name=""/>
           <p:cNvGraphicFramePr>
             <a:graphicFrameLocks xmlns:a="http://schemas.openxmlformats.org/drawingml/2006/main" noChangeAspect="1"/>
           </p:cNvGraphicFramePr>
@@ -5066,11 +5238,11 @@
               <p:embed/>
               <p:pic>
                 <p:nvPicPr>
-                  <p:cNvPr id="2055838269" name=""/>
+                  <p:cNvPr id="1575510896" name=""/>
                   <p:cNvPicPr/>
                   <p:nvPr/>
                 </p:nvPicPr>
-                <p:blipFill>
+                <p:blipFill rotWithShape="1">
                   <a:blip r:embed="rId3"/>
                   <a:stretch/>
                 </p:blipFill>
@@ -5090,13 +5262,13 @@
       </p:graphicFrame>
       <p:pic>
         <p:nvPicPr>
-          <p:cNvPr id="272346276" name=""/>
+          <p:cNvPr id="1933708396" name=""/>
           <p:cNvPicPr>
             <a:picLocks noChangeAspect="1"/>
           </p:cNvPicPr>
           <p:nvPr/>
         </p:nvPicPr>
-        <p:blipFill>
+        <p:blipFill rotWithShape="1">
           <a:blip r:embed="rId5"/>
           <a:stretch/>
         </p:blipFill>
@@ -5146,7 +5318,7 @@
       </p:grpSpPr>
       <p:sp>
         <p:nvSpPr>
-          <p:cNvPr id="212997840" name="Title 1"/>
+          <p:cNvPr id="1182859824" name="Title 1"/>
           <p:cNvSpPr>
             <a:spLocks noGrp="1"/>
           </p:cNvSpPr>
@@ -5189,7 +5361,7 @@
       </p:sp>
       <p:sp>
         <p:nvSpPr>
-          <p:cNvPr id="1472533797" name="Espace réservé du numéro de diapositive 5"/>
+          <p:cNvPr id="222987390" name="Espace réservé du numéro de diapositive 5"/>
           <p:cNvSpPr>
             <a:spLocks noGrp="1"/>
           </p:cNvSpPr>
@@ -5287,13 +5459,13 @@
       </p:sp>
       <p:pic>
         <p:nvPicPr>
-          <p:cNvPr id="2102280349" name=""/>
+          <p:cNvPr id="1057295687" name=""/>
           <p:cNvPicPr>
             <a:picLocks noChangeAspect="1"/>
           </p:cNvPicPr>
           <p:nvPr/>
         </p:nvPicPr>
-        <p:blipFill>
+        <p:blipFill rotWithShape="1">
           <a:blip r:embed="rId3"/>
           <a:stretch/>
         </p:blipFill>
@@ -5309,7 +5481,7 @@
       </p:pic>
       <p:graphicFrame>
         <p:nvGraphicFramePr>
-          <p:cNvPr id="876856094" name=""/>
+          <p:cNvPr id="286662936" name=""/>
           <p:cNvGraphicFramePr>
             <a:graphicFrameLocks xmlns:a="http://schemas.openxmlformats.org/drawingml/2006/main" noChangeAspect="1"/>
           </p:cNvGraphicFramePr>
@@ -5325,11 +5497,11 @@
               <p:embed/>
               <p:pic>
                 <p:nvPicPr>
-                  <p:cNvPr id="876856094" name=""/>
+                  <p:cNvPr id="286662936" name=""/>
                   <p:cNvPicPr/>
                   <p:nvPr/>
                 </p:nvPicPr>
-                <p:blipFill>
+                <p:blipFill rotWithShape="1">
                   <a:blip r:embed="rId4"/>
                   <a:stretch/>
                 </p:blipFill>
@@ -5383,7 +5555,7 @@
       </p:grpSpPr>
       <p:sp>
         <p:nvSpPr>
-          <p:cNvPr id="308946317" name="Title 1"/>
+          <p:cNvPr id="1735272941" name="Title 1"/>
           <p:cNvSpPr>
             <a:spLocks noGrp="1"/>
           </p:cNvSpPr>
@@ -5426,7 +5598,7 @@
       </p:sp>
       <p:sp>
         <p:nvSpPr>
-          <p:cNvPr id="1850280639" name="Espace réservé du numéro de diapositive 5"/>
+          <p:cNvPr id="1752471768" name="Espace réservé du numéro de diapositive 5"/>
           <p:cNvSpPr>
             <a:spLocks noGrp="1"/>
           </p:cNvSpPr>
@@ -5524,13 +5696,13 @@
       </p:sp>
       <p:pic>
         <p:nvPicPr>
-          <p:cNvPr id="366285945" name=""/>
+          <p:cNvPr id="2070067739" name=""/>
           <p:cNvPicPr>
             <a:picLocks noChangeAspect="1"/>
           </p:cNvPicPr>
           <p:nvPr/>
         </p:nvPicPr>
-        <p:blipFill>
+        <p:blipFill rotWithShape="1">
           <a:blip r:embed="rId3"/>
           <a:stretch/>
         </p:blipFill>
@@ -5546,7 +5718,7 @@
       </p:pic>
       <p:graphicFrame>
         <p:nvGraphicFramePr>
-          <p:cNvPr id="1394707192" name=""/>
+          <p:cNvPr id="1670898536" name=""/>
           <p:cNvGraphicFramePr>
             <a:graphicFrameLocks xmlns:a="http://schemas.openxmlformats.org/drawingml/2006/main" noChangeAspect="1"/>
           </p:cNvGraphicFramePr>
@@ -5562,11 +5734,11 @@
               <p:embed/>
               <p:pic>
                 <p:nvPicPr>
-                  <p:cNvPr id="1394707192" name=""/>
+                  <p:cNvPr id="1670898536" name=""/>
                   <p:cNvPicPr/>
                   <p:nvPr/>
                 </p:nvPicPr>
-                <p:blipFill>
+                <p:blipFill rotWithShape="1">
                   <a:blip r:embed="rId4"/>
                   <a:stretch/>
                 </p:blipFill>
@@ -5620,7 +5792,7 @@
       </p:grpSpPr>
       <p:sp>
         <p:nvSpPr>
-          <p:cNvPr id="1834710815" name="Title 1"/>
+          <p:cNvPr id="1607956197" name="Title 1"/>
           <p:cNvSpPr>
             <a:spLocks noGrp="1"/>
           </p:cNvSpPr>
@@ -5663,7 +5835,7 @@
       </p:sp>
       <p:sp>
         <p:nvSpPr>
-          <p:cNvPr id="1867918999" name="Espace réservé du numéro de diapositive 5"/>
+          <p:cNvPr id="871295222" name="Espace réservé du numéro de diapositive 5"/>
           <p:cNvSpPr>
             <a:spLocks noGrp="1"/>
           </p:cNvSpPr>
@@ -5761,13 +5933,13 @@
       </p:sp>
       <p:pic>
         <p:nvPicPr>
-          <p:cNvPr id="1549493064" name=""/>
+          <p:cNvPr id="1444678016" name=""/>
           <p:cNvPicPr>
             <a:picLocks noChangeAspect="1"/>
           </p:cNvPicPr>
           <p:nvPr/>
         </p:nvPicPr>
-        <p:blipFill>
+        <p:blipFill rotWithShape="1">
           <a:blip r:embed="rId3"/>
           <a:stretch/>
         </p:blipFill>
@@ -5783,7 +5955,7 @@
       </p:pic>
       <p:graphicFrame>
         <p:nvGraphicFramePr>
-          <p:cNvPr id="1139875001" name=""/>
+          <p:cNvPr id="2092136321" name=""/>
           <p:cNvGraphicFramePr>
             <a:graphicFrameLocks xmlns:a="http://schemas.openxmlformats.org/drawingml/2006/main" noChangeAspect="1"/>
           </p:cNvGraphicFramePr>
@@ -5799,11 +5971,11 @@
               <p:embed/>
               <p:pic>
                 <p:nvPicPr>
-                  <p:cNvPr id="1139875001" name=""/>
+                  <p:cNvPr id="2092136321" name=""/>
                   <p:cNvPicPr/>
                   <p:nvPr/>
                 </p:nvPicPr>
-                <p:blipFill>
+                <p:blipFill rotWithShape="1">
                   <a:blip r:embed="rId4"/>
                   <a:stretch/>
                 </p:blipFill>
@@ -5857,7 +6029,7 @@
       </p:grpSpPr>
       <p:sp>
         <p:nvSpPr>
-          <p:cNvPr id="1876528393" name="Title 1"/>
+          <p:cNvPr id="513223972" name="Title 1"/>
           <p:cNvSpPr>
             <a:spLocks noGrp="1"/>
           </p:cNvSpPr>
@@ -5900,7 +6072,7 @@
       </p:sp>
       <p:sp>
         <p:nvSpPr>
-          <p:cNvPr id="1130684099" name="Espace réservé du numéro de diapositive 5"/>
+          <p:cNvPr id="1096917330" name="Espace réservé du numéro de diapositive 5"/>
           <p:cNvSpPr>
             <a:spLocks noGrp="1"/>
           </p:cNvSpPr>
@@ -5998,13 +6170,13 @@
       </p:sp>
       <p:pic>
         <p:nvPicPr>
-          <p:cNvPr id="927569989" name=""/>
+          <p:cNvPr id="466815796" name=""/>
           <p:cNvPicPr>
             <a:picLocks noChangeAspect="1"/>
           </p:cNvPicPr>
           <p:nvPr/>
         </p:nvPicPr>
-        <p:blipFill>
+        <p:blipFill rotWithShape="1">
           <a:blip r:embed="rId3"/>
           <a:stretch/>
         </p:blipFill>
@@ -6020,7 +6192,7 @@
       </p:pic>
       <p:graphicFrame>
         <p:nvGraphicFramePr>
-          <p:cNvPr id="55863096" name=""/>
+          <p:cNvPr id="1586223941" name=""/>
           <p:cNvGraphicFramePr>
             <a:graphicFrameLocks xmlns:a="http://schemas.openxmlformats.org/drawingml/2006/main" noChangeAspect="1"/>
           </p:cNvGraphicFramePr>
@@ -6036,11 +6208,11 @@
               <p:embed/>
               <p:pic>
                 <p:nvPicPr>
-                  <p:cNvPr id="55863096" name=""/>
+                  <p:cNvPr id="1586223941" name=""/>
                   <p:cNvPicPr/>
                   <p:nvPr/>
                 </p:nvPicPr>
-                <p:blipFill>
+                <p:blipFill rotWithShape="1">
                   <a:blip r:embed="rId4"/>
                   <a:stretch/>
                 </p:blipFill>
@@ -6060,13 +6232,13 @@
       </p:graphicFrame>
       <p:pic>
         <p:nvPicPr>
-          <p:cNvPr id="1531058207" name=""/>
+          <p:cNvPr id="38990329" name=""/>
           <p:cNvPicPr>
             <a:picLocks noChangeAspect="1"/>
           </p:cNvPicPr>
           <p:nvPr/>
         </p:nvPicPr>
-        <p:blipFill>
+        <p:blipFill rotWithShape="1">
           <a:blip r:embed="rId6"/>
           <a:stretch/>
         </p:blipFill>
@@ -6116,7 +6288,7 @@
       </p:grpSpPr>
       <p:sp>
         <p:nvSpPr>
-          <p:cNvPr id="1565757651" name="Title 1"/>
+          <p:cNvPr id="85229633" name="Title 1"/>
           <p:cNvSpPr>
             <a:spLocks noGrp="1"/>
           </p:cNvSpPr>
@@ -6159,7 +6331,7 @@
       </p:sp>
       <p:sp>
         <p:nvSpPr>
-          <p:cNvPr id="576050472" name="Espace réservé du numéro de diapositive 5"/>
+          <p:cNvPr id="1957721547" name="Espace réservé du numéro de diapositive 5"/>
           <p:cNvSpPr>
             <a:spLocks noGrp="1"/>
           </p:cNvSpPr>
@@ -6257,13 +6429,13 @@
       </p:sp>
       <p:pic>
         <p:nvPicPr>
-          <p:cNvPr id="1429318256" name=""/>
+          <p:cNvPr id="2035223705" name=""/>
           <p:cNvPicPr>
             <a:picLocks noChangeAspect="1"/>
           </p:cNvPicPr>
           <p:nvPr/>
         </p:nvPicPr>
-        <p:blipFill>
+        <p:blipFill rotWithShape="1">
           <a:blip r:embed="rId3"/>
           <a:stretch/>
         </p:blipFill>
@@ -6279,7 +6451,7 @@
       </p:pic>
       <p:graphicFrame>
         <p:nvGraphicFramePr>
-          <p:cNvPr id="1961374193" name=""/>
+          <p:cNvPr id="1593897518" name=""/>
           <p:cNvGraphicFramePr>
             <a:graphicFrameLocks xmlns:a="http://schemas.openxmlformats.org/drawingml/2006/main" noChangeAspect="1"/>
           </p:cNvGraphicFramePr>
@@ -6295,11 +6467,11 @@
               <p:embed/>
               <p:pic>
                 <p:nvPicPr>
-                  <p:cNvPr id="1961374193" name=""/>
+                  <p:cNvPr id="1593897518" name=""/>
                   <p:cNvPicPr/>
                   <p:nvPr/>
                 </p:nvPicPr>
-                <p:blipFill>
+                <p:blipFill rotWithShape="1">
                   <a:blip r:embed="rId4"/>
                   <a:stretch/>
                 </p:blipFill>
@@ -6319,13 +6491,13 @@
       </p:graphicFrame>
       <p:pic>
         <p:nvPicPr>
-          <p:cNvPr id="1583274626" name=""/>
+          <p:cNvPr id="174920006" name=""/>
           <p:cNvPicPr>
             <a:picLocks noChangeAspect="1"/>
           </p:cNvPicPr>
           <p:nvPr/>
         </p:nvPicPr>
-        <p:blipFill>
+        <p:blipFill rotWithShape="1">
           <a:blip r:embed="rId6"/>
           <a:stretch/>
         </p:blipFill>
@@ -6375,7 +6547,7 @@
       </p:grpSpPr>
       <p:sp>
         <p:nvSpPr>
-          <p:cNvPr id="1189682143" name="Title 1"/>
+          <p:cNvPr id="736834045" name="Title 1"/>
           <p:cNvSpPr>
             <a:spLocks noGrp="1"/>
           </p:cNvSpPr>
@@ -6418,7 +6590,7 @@
       </p:sp>
       <p:sp>
         <p:nvSpPr>
-          <p:cNvPr id="681811888" name="Espace réservé du numéro de diapositive 5"/>
+          <p:cNvPr id="990804862" name="Espace réservé du numéro de diapositive 5"/>
           <p:cNvSpPr>
             <a:spLocks noGrp="1"/>
           </p:cNvSpPr>
@@ -6506,7 +6678,7 @@
             <a:pPr>
               <a:defRPr/>
             </a:pPr>
-            <a:fld id="{690C5A4F-4E88-BF87-ADD8-9CB41341CAAE}" type="slidenum">
+            <a:fld id="{9D784AE7-E891-3883-60C9-410A3E3DD19E}" type="slidenum">
               <a:rPr lang="fr-FR"/>
               <a:t/>
             </a:fld>
@@ -6516,13 +6688,13 @@
       </p:sp>
       <p:pic>
         <p:nvPicPr>
-          <p:cNvPr id="1390147898" name=""/>
+          <p:cNvPr id="958327912" name=""/>
           <p:cNvPicPr>
             <a:picLocks noChangeAspect="1"/>
           </p:cNvPicPr>
           <p:nvPr/>
         </p:nvPicPr>
-        <p:blipFill>
+        <p:blipFill rotWithShape="1">
           <a:blip r:embed="rId3"/>
           <a:stretch/>
         </p:blipFill>
@@ -6538,7 +6710,7 @@
       </p:pic>
       <p:graphicFrame>
         <p:nvGraphicFramePr>
-          <p:cNvPr id="1974346743" name=""/>
+          <p:cNvPr id="684219704" name=""/>
           <p:cNvGraphicFramePr>
             <a:graphicFrameLocks xmlns:a="http://schemas.openxmlformats.org/drawingml/2006/main" noChangeAspect="1"/>
           </p:cNvGraphicFramePr>
@@ -6546,26 +6718,26 @@
         </p:nvGraphicFramePr>
         <p:xfrm flipH="0" flipV="0">
           <a:off x="1255546" y="1345492"/>
-          <a:ext cx="1512000" cy="540000"/>
+          <a:ext cx="1800000" cy="648000"/>
         </p:xfrm>
         <a:graphic>
           <a:graphicData uri="http://schemas.openxmlformats.org/presentationml/2006/ole">
-            <p:oleObj name="oleObj" r:id="rId5" imgW="1504950" imgH="533400" progId="asc.{DB38923B-A8C0-4DE9-8AEE-A61BB5C901A5}">
+            <p:oleObj name="oleObj" r:id="rId5" imgW="1790700" imgH="647700" progId="asc.{DB38923B-A8C0-4DE9-8AEE-A61BB5C901A5}">
               <p:embed/>
               <p:pic>
                 <p:nvPicPr>
-                  <p:cNvPr id="1974346743" name=""/>
+                  <p:cNvPr id="684219704" name=""/>
                   <p:cNvPicPr/>
                   <p:nvPr/>
                 </p:nvPicPr>
-                <p:blipFill>
+                <p:blipFill rotWithShape="1">
                   <a:blip r:embed="rId4"/>
                   <a:stretch/>
                 </p:blipFill>
                 <p:spPr bwMode="auto">
                   <a:xfrm flipH="0" flipV="0">
                     <a:off x="1255546" y="1345492"/>
-                    <a:ext cx="1512000" cy="540000"/>
+                    <a:ext cx="1800000" cy="648000"/>
                   </a:xfrm>
                   <a:prstGeom prst="rect">
                     <a:avLst/>
@@ -6578,20 +6750,20 @@
       </p:graphicFrame>
       <p:pic>
         <p:nvPicPr>
-          <p:cNvPr id="406457233" name=""/>
+          <p:cNvPr id="1297933076" name=""/>
           <p:cNvPicPr>
             <a:picLocks noChangeAspect="1"/>
           </p:cNvPicPr>
           <p:nvPr/>
         </p:nvPicPr>
-        <p:blipFill>
+        <p:blipFill rotWithShape="1">
           <a:blip r:embed="rId6"/>
           <a:stretch/>
         </p:blipFill>
         <p:spPr bwMode="auto">
           <a:xfrm flipH="0" flipV="0">
-            <a:off x="1600580" y="40700"/>
-            <a:ext cx="8589508" cy="6776598"/>
+            <a:off x="3408050" y="218203"/>
+            <a:ext cx="5558569" cy="6639796"/>
           </a:xfrm>
           <a:prstGeom prst="rect">
             <a:avLst/>
@@ -6634,7 +6806,7 @@
       </p:grpSpPr>
       <p:sp>
         <p:nvSpPr>
-          <p:cNvPr id="1004037592" name="Title 1"/>
+          <p:cNvPr id="1675836100" name="Title 1"/>
           <p:cNvSpPr>
             <a:spLocks noGrp="1"/>
           </p:cNvSpPr>
@@ -6666,7 +6838,7 @@
       </p:sp>
       <p:sp>
         <p:nvSpPr>
-          <p:cNvPr id="1337844691" name="Content Placeholder 2"/>
+          <p:cNvPr id="815628860" name="Content Placeholder 2"/>
           <p:cNvSpPr>
             <a:spLocks noGrp="1"/>
           </p:cNvSpPr>
@@ -6718,7 +6890,7 @@
                 </a:solidFill>
                 <a:hlinkClick r:id="rId4" action="ppaction://hlinksldjump" tooltip="Diapositive 5"/>
               </a:rPr>
-              <a:t>2. Présentation et démonstration du tableau de bord</a:t>
+              <a:t>2. Présentation technique de l’application</a:t>
             </a:r>
             <a:endParaRPr sz="1700" b="1" u="sng">
               <a:solidFill>
@@ -6740,7 +6912,7 @@
                 </a:solidFill>
                 <a:hlinkClick r:id="rId5" action="ppaction://hlinksldjump" tooltip="Diapositive 7"/>
               </a:rPr>
-              <a:t>3 Présentation du dashboard</a:t>
+              <a:t>3 Démonstration de l’application</a:t>
             </a:r>
             <a:endParaRPr sz="1700" b="1" u="sng">
               <a:solidFill>
@@ -6821,7 +6993,7 @@
       </p:sp>
       <p:sp>
         <p:nvSpPr>
-          <p:cNvPr id="1997470055" name="Espace réservé du numéro de diapositive 5"/>
+          <p:cNvPr id="1021263118" name="Espace réservé du numéro de diapositive 5"/>
           <p:cNvSpPr>
             <a:spLocks noGrp="1"/>
           </p:cNvSpPr>
@@ -6932,7 +7104,7 @@
   </mc:AlternateContent>
   <p:timing>
     <p:bldLst>
-      <p:bldP spid="1337844691" grpId="0" uiExpand="1" build="p"/>
+      <p:bldP spid="815628860" grpId="0" uiExpand="1" build="p"/>
     </p:bldLst>
   </p:timing>
 </p:sld>
@@ -6957,7 +7129,525 @@
       </p:grpSpPr>
       <p:sp>
         <p:nvSpPr>
-          <p:cNvPr id="979385862" name="Title 1"/>
+          <p:cNvPr id="1498117767" name="Title 1"/>
+          <p:cNvSpPr>
+            <a:spLocks noGrp="1"/>
+          </p:cNvSpPr>
+          <p:nvPr>
+            <p:ph type="title"/>
+          </p:nvPr>
+        </p:nvSpPr>
+        <p:spPr bwMode="auto">
+          <a:xfrm flipH="0" flipV="0">
+            <a:off x="1077600" y="365121"/>
+            <a:ext cx="10036791" cy="1325556"/>
+          </a:xfrm>
+        </p:spPr>
+        <p:txBody>
+          <a:bodyPr/>
+          <a:lstStyle/>
+          <a:p>
+            <a:pPr marL="0" lvl="0" indent="0">
+              <a:buNone/>
+              <a:defRPr/>
+            </a:pPr>
+            <a:r>
+              <a:rPr lang="fr-FR" sz="3600" b="0" i="0" u="none" strike="noStrike" cap="none" spc="0">
+                <a:solidFill>
+                  <a:srgbClr val="404040"/>
+                </a:solidFill>
+                <a:latin typeface="Orkney Medium"/>
+                <a:ea typeface="Orkney Medium"/>
+                <a:cs typeface="Orkney Medium"/>
+              </a:rPr>
+              <a:t>5 </a:t>
+            </a:r>
+            <a:r>
+              <a:rPr sz="3600"/>
+              <a:t>Comparaison de modèles d’embeddings</a:t>
+            </a:r>
+            <a:endParaRPr sz="3600"/>
+          </a:p>
+        </p:txBody>
+      </p:sp>
+      <p:sp>
+        <p:nvSpPr>
+          <p:cNvPr id="1471381412" name="Espace réservé du numéro de diapositive 5"/>
+          <p:cNvSpPr>
+            <a:spLocks noGrp="1"/>
+          </p:cNvSpPr>
+          <p:nvPr>
+            <p:ph type="sldNum" sz="quarter" idx="4"/>
+          </p:nvPr>
+        </p:nvSpPr>
+        <p:spPr bwMode="auto">
+          <a:xfrm>
+            <a:off x="9351930" y="980370"/>
+            <a:ext cx="2743200" cy="365121"/>
+          </a:xfrm>
+          <a:prstGeom prst="rect">
+            <a:avLst/>
+          </a:prstGeom>
+        </p:spPr>
+        <p:txBody>
+          <a:bodyPr vert="horz" lIns="91440" tIns="45720" rIns="91440" bIns="45720" rtlCol="0" anchor="ctr"/>
+          <a:lstStyle>
+            <a:lvl1pPr algn="r">
+              <a:defRPr sz="1600" b="1">
+                <a:solidFill>
+                  <a:schemeClr val="bg1"/>
+                </a:solidFill>
+              </a:defRPr>
+            </a:lvl1pPr>
+            <a:lvl2pPr>
+              <a:defRPr sz="2200" b="1">
+                <a:solidFill>
+                  <a:schemeClr val="bg1"/>
+                </a:solidFill>
+              </a:defRPr>
+            </a:lvl2pPr>
+            <a:lvl3pPr>
+              <a:defRPr sz="2200" b="1">
+                <a:solidFill>
+                  <a:schemeClr val="bg1"/>
+                </a:solidFill>
+              </a:defRPr>
+            </a:lvl3pPr>
+            <a:lvl4pPr>
+              <a:defRPr sz="2200" b="1">
+                <a:solidFill>
+                  <a:schemeClr val="bg1"/>
+                </a:solidFill>
+              </a:defRPr>
+            </a:lvl4pPr>
+            <a:lvl5pPr>
+              <a:defRPr sz="2200" b="1">
+                <a:solidFill>
+                  <a:schemeClr val="bg1"/>
+                </a:solidFill>
+              </a:defRPr>
+            </a:lvl5pPr>
+            <a:lvl6pPr>
+              <a:defRPr sz="2200" b="1">
+                <a:solidFill>
+                  <a:schemeClr val="bg1"/>
+                </a:solidFill>
+              </a:defRPr>
+            </a:lvl6pPr>
+            <a:lvl7pPr>
+              <a:defRPr sz="2200" b="1">
+                <a:solidFill>
+                  <a:schemeClr val="bg1"/>
+                </a:solidFill>
+              </a:defRPr>
+            </a:lvl7pPr>
+            <a:lvl8pPr>
+              <a:defRPr sz="2200" b="1">
+                <a:solidFill>
+                  <a:schemeClr val="bg1"/>
+                </a:solidFill>
+              </a:defRPr>
+            </a:lvl8pPr>
+            <a:lvl9pPr>
+              <a:defRPr sz="2200" b="1">
+                <a:solidFill>
+                  <a:schemeClr val="bg1"/>
+                </a:solidFill>
+              </a:defRPr>
+            </a:lvl9pPr>
+          </a:lstStyle>
+          <a:p>
+            <a:pPr>
+              <a:defRPr/>
+            </a:pPr>
+            <a:fld id="{2C06556E-05FC-4556-382C-ED08BBDD5A6E}" type="slidenum">
+              <a:rPr lang="fr-FR"/>
+              <a:t/>
+            </a:fld>
+            <a:endParaRPr/>
+          </a:p>
+        </p:txBody>
+      </p:sp>
+      <p:pic>
+        <p:nvPicPr>
+          <p:cNvPr id="677552966" name=""/>
+          <p:cNvPicPr>
+            <a:picLocks noChangeAspect="1"/>
+          </p:cNvPicPr>
+          <p:nvPr/>
+        </p:nvPicPr>
+        <p:blipFill rotWithShape="1">
+          <a:blip r:embed="rId3"/>
+          <a:stretch/>
+        </p:blipFill>
+        <p:spPr bwMode="auto">
+          <a:xfrm flipH="0" flipV="0">
+            <a:off x="10477498" y="5989447"/>
+            <a:ext cx="1520123" cy="760060"/>
+          </a:xfrm>
+          <a:prstGeom prst="rect">
+            <a:avLst/>
+          </a:prstGeom>
+        </p:spPr>
+      </p:pic>
+      <p:graphicFrame>
+        <p:nvGraphicFramePr>
+          <p:cNvPr id="1614273013" name=""/>
+          <p:cNvGraphicFramePr>
+            <a:graphicFrameLocks xmlns:a="http://schemas.openxmlformats.org/drawingml/2006/main" noChangeAspect="1"/>
+          </p:cNvGraphicFramePr>
+          <p:nvPr/>
+        </p:nvGraphicFramePr>
+        <p:xfrm flipH="0" flipV="0">
+          <a:off x="1255546" y="1345492"/>
+          <a:ext cx="1800000" cy="648000"/>
+        </p:xfrm>
+        <a:graphic>
+          <a:graphicData uri="http://schemas.openxmlformats.org/presentationml/2006/ole">
+            <p:oleObj name="oleObj" r:id="rId5" imgW="1790700" imgH="647700" progId="asc.{DB38923B-A8C0-4DE9-8AEE-A61BB5C901A5}">
+              <p:embed/>
+              <p:pic>
+                <p:nvPicPr>
+                  <p:cNvPr id="1614273013" name=""/>
+                  <p:cNvPicPr/>
+                  <p:nvPr/>
+                </p:nvPicPr>
+                <p:blipFill rotWithShape="1">
+                  <a:blip r:embed="rId4"/>
+                  <a:stretch/>
+                </p:blipFill>
+                <p:spPr bwMode="auto">
+                  <a:xfrm flipH="0" flipV="0">
+                    <a:off x="1255546" y="1345492"/>
+                    <a:ext cx="1800000" cy="648000"/>
+                  </a:xfrm>
+                  <a:prstGeom prst="rect">
+                    <a:avLst/>
+                  </a:prstGeom>
+                </p:spPr>
+              </p:pic>
+            </p:oleObj>
+          </a:graphicData>
+        </a:graphic>
+      </p:graphicFrame>
+      <p:pic>
+        <p:nvPicPr>
+          <p:cNvPr id="1380546371" name=""/>
+          <p:cNvPicPr>
+            <a:picLocks noChangeAspect="1"/>
+          </p:cNvPicPr>
+          <p:nvPr/>
+        </p:nvPicPr>
+        <p:blipFill rotWithShape="1">
+          <a:blip r:embed="rId6"/>
+          <a:stretch/>
+        </p:blipFill>
+        <p:spPr bwMode="auto">
+          <a:xfrm flipH="0" flipV="0">
+            <a:off x="3118469" y="545585"/>
+            <a:ext cx="7359028" cy="5908812"/>
+          </a:xfrm>
+          <a:prstGeom prst="rect">
+            <a:avLst/>
+          </a:prstGeom>
+        </p:spPr>
+      </p:pic>
+    </p:spTree>
+  </p:cSld>
+  <p:clrMapOvr>
+    <a:masterClrMapping/>
+  </p:clrMapOvr>
+  <mc:AlternateContent xmlns:mc="http://schemas.openxmlformats.org/markup-compatibility/2006">
+    <mc:Choice xmlns:p159="http://schemas.microsoft.com/office/powerpoint/2015/09/main" xmlns:p14="http://schemas.microsoft.com/office/powerpoint/2010/main" Requires="p159">
+      <p:transition p14:dur="2000" advClick="1"/>
+    </mc:Choice>
+    <mc:Fallback>
+      <p:transition advClick="1"/>
+    </mc:Fallback>
+  </mc:AlternateContent>
+  <p:timing/>
+</p:sld>
+</file>
+
+<file path=ppt/slides/slide21.xml><?xml version="1.0" encoding="utf-8"?>
+<p:sld xmlns:a="http://schemas.openxmlformats.org/drawingml/2006/main" xmlns:r="http://schemas.openxmlformats.org/officeDocument/2006/relationships" xmlns:p="http://schemas.openxmlformats.org/presentationml/2006/main" xmlns:m="http://schemas.openxmlformats.org/officeDocument/2006/math" xmlns:w="http://schemas.openxmlformats.org/wordprocessingml/2006/main" xmlns:mc="http://schemas.openxmlformats.org/markup-compatibility/2006" showMasterPhAnim="0" showMasterSp="1" show="1">
+  <p:cSld name="">
+    <p:spTree>
+      <p:nvGrpSpPr>
+        <p:cNvPr id="1" name=""/>
+        <p:cNvGrpSpPr/>
+        <p:nvPr/>
+      </p:nvGrpSpPr>
+      <p:grpSpPr bwMode="auto">
+        <a:xfrm>
+          <a:off x="0" y="0"/>
+          <a:ext cx="0" cy="0"/>
+          <a:chOff x="0" y="0"/>
+          <a:chExt cx="0" cy="0"/>
+        </a:xfrm>
+      </p:grpSpPr>
+      <p:sp>
+        <p:nvSpPr>
+          <p:cNvPr id="1062982906" name="Title 1"/>
+          <p:cNvSpPr>
+            <a:spLocks noGrp="1"/>
+          </p:cNvSpPr>
+          <p:nvPr>
+            <p:ph type="title"/>
+          </p:nvPr>
+        </p:nvSpPr>
+        <p:spPr bwMode="auto">
+          <a:xfrm flipH="0" flipV="0">
+            <a:off x="1077600" y="365121"/>
+            <a:ext cx="10036791" cy="1325556"/>
+          </a:xfrm>
+        </p:spPr>
+        <p:txBody>
+          <a:bodyPr/>
+          <a:lstStyle/>
+          <a:p>
+            <a:pPr marL="0" lvl="0" indent="0">
+              <a:buNone/>
+              <a:defRPr/>
+            </a:pPr>
+            <a:r>
+              <a:rPr lang="fr-FR" sz="3600" b="0" i="0" u="none" strike="noStrike" cap="none" spc="0">
+                <a:solidFill>
+                  <a:srgbClr val="404040"/>
+                </a:solidFill>
+                <a:latin typeface="Orkney Medium"/>
+                <a:ea typeface="Orkney Medium"/>
+                <a:cs typeface="Orkney Medium"/>
+              </a:rPr>
+              <a:t>5 </a:t>
+            </a:r>
+            <a:r>
+              <a:rPr sz="3600"/>
+              <a:t>Comparaison de modèles d’embeddings</a:t>
+            </a:r>
+            <a:endParaRPr sz="3600"/>
+          </a:p>
+        </p:txBody>
+      </p:sp>
+      <p:sp>
+        <p:nvSpPr>
+          <p:cNvPr id="261628962" name="Espace réservé du numéro de diapositive 5"/>
+          <p:cNvSpPr>
+            <a:spLocks noGrp="1"/>
+          </p:cNvSpPr>
+          <p:nvPr>
+            <p:ph type="sldNum" sz="quarter" idx="4"/>
+          </p:nvPr>
+        </p:nvSpPr>
+        <p:spPr bwMode="auto">
+          <a:xfrm>
+            <a:off x="9351930" y="980370"/>
+            <a:ext cx="2743200" cy="365121"/>
+          </a:xfrm>
+          <a:prstGeom prst="rect">
+            <a:avLst/>
+          </a:prstGeom>
+        </p:spPr>
+        <p:txBody>
+          <a:bodyPr vert="horz" lIns="91440" tIns="45720" rIns="91440" bIns="45720" rtlCol="0" anchor="ctr"/>
+          <a:lstStyle>
+            <a:lvl1pPr algn="r">
+              <a:defRPr sz="1600" b="1">
+                <a:solidFill>
+                  <a:schemeClr val="bg1"/>
+                </a:solidFill>
+              </a:defRPr>
+            </a:lvl1pPr>
+            <a:lvl2pPr>
+              <a:defRPr sz="2200" b="1">
+                <a:solidFill>
+                  <a:schemeClr val="bg1"/>
+                </a:solidFill>
+              </a:defRPr>
+            </a:lvl2pPr>
+            <a:lvl3pPr>
+              <a:defRPr sz="2200" b="1">
+                <a:solidFill>
+                  <a:schemeClr val="bg1"/>
+                </a:solidFill>
+              </a:defRPr>
+            </a:lvl3pPr>
+            <a:lvl4pPr>
+              <a:defRPr sz="2200" b="1">
+                <a:solidFill>
+                  <a:schemeClr val="bg1"/>
+                </a:solidFill>
+              </a:defRPr>
+            </a:lvl4pPr>
+            <a:lvl5pPr>
+              <a:defRPr sz="2200" b="1">
+                <a:solidFill>
+                  <a:schemeClr val="bg1"/>
+                </a:solidFill>
+              </a:defRPr>
+            </a:lvl5pPr>
+            <a:lvl6pPr>
+              <a:defRPr sz="2200" b="1">
+                <a:solidFill>
+                  <a:schemeClr val="bg1"/>
+                </a:solidFill>
+              </a:defRPr>
+            </a:lvl6pPr>
+            <a:lvl7pPr>
+              <a:defRPr sz="2200" b="1">
+                <a:solidFill>
+                  <a:schemeClr val="bg1"/>
+                </a:solidFill>
+              </a:defRPr>
+            </a:lvl7pPr>
+            <a:lvl8pPr>
+              <a:defRPr sz="2200" b="1">
+                <a:solidFill>
+                  <a:schemeClr val="bg1"/>
+                </a:solidFill>
+              </a:defRPr>
+            </a:lvl8pPr>
+            <a:lvl9pPr>
+              <a:defRPr sz="2200" b="1">
+                <a:solidFill>
+                  <a:schemeClr val="bg1"/>
+                </a:solidFill>
+              </a:defRPr>
+            </a:lvl9pPr>
+          </a:lstStyle>
+          <a:p>
+            <a:pPr>
+              <a:defRPr/>
+            </a:pPr>
+            <a:fld id="{690C5A4F-4E88-BF87-ADD8-9CB41341CAAE}" type="slidenum">
+              <a:rPr lang="fr-FR"/>
+              <a:t/>
+            </a:fld>
+            <a:endParaRPr/>
+          </a:p>
+        </p:txBody>
+      </p:sp>
+      <p:pic>
+        <p:nvPicPr>
+          <p:cNvPr id="877608679" name=""/>
+          <p:cNvPicPr>
+            <a:picLocks noChangeAspect="1"/>
+          </p:cNvPicPr>
+          <p:nvPr/>
+        </p:nvPicPr>
+        <p:blipFill rotWithShape="1">
+          <a:blip r:embed="rId3"/>
+          <a:stretch/>
+        </p:blipFill>
+        <p:spPr bwMode="auto">
+          <a:xfrm flipH="0" flipV="0">
+            <a:off x="10477498" y="5989447"/>
+            <a:ext cx="1520123" cy="760060"/>
+          </a:xfrm>
+          <a:prstGeom prst="rect">
+            <a:avLst/>
+          </a:prstGeom>
+        </p:spPr>
+      </p:pic>
+      <p:graphicFrame>
+        <p:nvGraphicFramePr>
+          <p:cNvPr id="1695732773" name=""/>
+          <p:cNvGraphicFramePr>
+            <a:graphicFrameLocks xmlns:a="http://schemas.openxmlformats.org/drawingml/2006/main" noChangeAspect="1"/>
+          </p:cNvGraphicFramePr>
+          <p:nvPr/>
+        </p:nvGraphicFramePr>
+        <p:xfrm flipH="0" flipV="0">
+          <a:off x="1255546" y="1345492"/>
+          <a:ext cx="1512000" cy="540000"/>
+        </p:xfrm>
+        <a:graphic>
+          <a:graphicData uri="http://schemas.openxmlformats.org/presentationml/2006/ole">
+            <p:oleObj name="oleObj" r:id="rId5" imgW="1504950" imgH="533400" progId="asc.{DB38923B-A8C0-4DE9-8AEE-A61BB5C901A5}">
+              <p:embed/>
+              <p:pic>
+                <p:nvPicPr>
+                  <p:cNvPr id="1695732773" name=""/>
+                  <p:cNvPicPr/>
+                  <p:nvPr/>
+                </p:nvPicPr>
+                <p:blipFill rotWithShape="1">
+                  <a:blip r:embed="rId4"/>
+                  <a:stretch/>
+                </p:blipFill>
+                <p:spPr bwMode="auto">
+                  <a:xfrm flipH="0" flipV="0">
+                    <a:off x="1255546" y="1345492"/>
+                    <a:ext cx="1512000" cy="540000"/>
+                  </a:xfrm>
+                  <a:prstGeom prst="rect">
+                    <a:avLst/>
+                  </a:prstGeom>
+                </p:spPr>
+              </p:pic>
+            </p:oleObj>
+          </a:graphicData>
+        </a:graphic>
+      </p:graphicFrame>
+      <p:pic>
+        <p:nvPicPr>
+          <p:cNvPr id="1966730470" name=""/>
+          <p:cNvPicPr>
+            <a:picLocks noChangeAspect="1"/>
+          </p:cNvPicPr>
+          <p:nvPr/>
+        </p:nvPicPr>
+        <p:blipFill rotWithShape="1">
+          <a:blip r:embed="rId6"/>
+          <a:stretch/>
+        </p:blipFill>
+        <p:spPr bwMode="auto">
+          <a:xfrm flipH="0" flipV="0">
+            <a:off x="1600580" y="40700"/>
+            <a:ext cx="8589508" cy="6776598"/>
+          </a:xfrm>
+          <a:prstGeom prst="rect">
+            <a:avLst/>
+          </a:prstGeom>
+        </p:spPr>
+      </p:pic>
+    </p:spTree>
+  </p:cSld>
+  <p:clrMapOvr>
+    <a:masterClrMapping/>
+  </p:clrMapOvr>
+  <mc:AlternateContent xmlns:mc="http://schemas.openxmlformats.org/markup-compatibility/2006">
+    <mc:Choice xmlns:p159="http://schemas.microsoft.com/office/powerpoint/2015/09/main" xmlns:p14="http://schemas.microsoft.com/office/powerpoint/2010/main" Requires="p159">
+      <p:transition p14:dur="2000" advClick="1"/>
+    </mc:Choice>
+    <mc:Fallback>
+      <p:transition advClick="1"/>
+    </mc:Fallback>
+  </mc:AlternateContent>
+  <p:timing/>
+</p:sld>
+</file>
+
+<file path=ppt/slides/slide22.xml><?xml version="1.0" encoding="utf-8"?>
+<p:sld xmlns:a="http://schemas.openxmlformats.org/drawingml/2006/main" xmlns:r="http://schemas.openxmlformats.org/officeDocument/2006/relationships" xmlns:p="http://schemas.openxmlformats.org/presentationml/2006/main" xmlns:m="http://schemas.openxmlformats.org/officeDocument/2006/math" xmlns:w="http://schemas.openxmlformats.org/wordprocessingml/2006/main" xmlns:mc="http://schemas.openxmlformats.org/markup-compatibility/2006" showMasterPhAnim="0" showMasterSp="1" show="1">
+  <p:cSld name="">
+    <p:spTree>
+      <p:nvGrpSpPr>
+        <p:cNvPr id="1" name=""/>
+        <p:cNvGrpSpPr/>
+        <p:nvPr/>
+      </p:nvGrpSpPr>
+      <p:grpSpPr bwMode="auto">
+        <a:xfrm>
+          <a:off x="0" y="0"/>
+          <a:ext cx="0" cy="0"/>
+          <a:chOff x="0" y="0"/>
+          <a:chExt cx="0" cy="0"/>
+        </a:xfrm>
+      </p:grpSpPr>
+      <p:sp>
+        <p:nvSpPr>
+          <p:cNvPr id="680710670" name="Title 1"/>
           <p:cNvSpPr>
             <a:spLocks noGrp="1"/>
           </p:cNvSpPr>
@@ -6996,7 +7686,7 @@
       </p:sp>
       <p:sp>
         <p:nvSpPr>
-          <p:cNvPr id="1370897295" name="Espace réservé du numéro de diapositive 5"/>
+          <p:cNvPr id="1500271125" name="Espace réservé du numéro de diapositive 5"/>
           <p:cNvSpPr>
             <a:spLocks noGrp="1"/>
           </p:cNvSpPr>
@@ -7094,13 +7784,13 @@
       </p:sp>
       <p:pic>
         <p:nvPicPr>
-          <p:cNvPr id="705236955" name=""/>
+          <p:cNvPr id="220441325" name=""/>
           <p:cNvPicPr>
             <a:picLocks noChangeAspect="1"/>
           </p:cNvPicPr>
           <p:nvPr/>
         </p:nvPicPr>
-        <p:blipFill>
+        <p:blipFill rotWithShape="1">
           <a:blip r:embed="rId3"/>
           <a:stretch/>
         </p:blipFill>
@@ -7130,7 +7820,7 @@
 </p:sld>
 </file>
 
-<file path=ppt/slides/slide21.xml><?xml version="1.0" encoding="utf-8"?>
+<file path=ppt/slides/slide23.xml><?xml version="1.0" encoding="utf-8"?>
 <p:sld xmlns:a="http://schemas.openxmlformats.org/drawingml/2006/main" xmlns:r="http://schemas.openxmlformats.org/officeDocument/2006/relationships" xmlns:p="http://schemas.openxmlformats.org/presentationml/2006/main" xmlns:m="http://schemas.openxmlformats.org/officeDocument/2006/math" xmlns:w="http://schemas.openxmlformats.org/wordprocessingml/2006/main" xmlns:mc="http://schemas.openxmlformats.org/markup-compatibility/2006" showMasterPhAnim="0" showMasterSp="1" show="1">
   <p:cSld name="">
     <p:spTree>
@@ -7149,7 +7839,7 @@
       </p:grpSpPr>
       <p:sp>
         <p:nvSpPr>
-          <p:cNvPr id="1335802661" name="Title 1"/>
+          <p:cNvPr id="1292364208" name="Title 1"/>
           <p:cNvSpPr>
             <a:spLocks noGrp="1"/>
           </p:cNvSpPr>
@@ -7181,7 +7871,7 @@
       </p:sp>
       <p:sp>
         <p:nvSpPr>
-          <p:cNvPr id="1647387496" name="Espace réservé du numéro de diapositive 5"/>
+          <p:cNvPr id="1276204242" name="Espace réservé du numéro de diapositive 5"/>
           <p:cNvSpPr>
             <a:spLocks noGrp="1"/>
           </p:cNvSpPr>
@@ -7279,13 +7969,13 @@
       </p:sp>
       <p:pic>
         <p:nvPicPr>
-          <p:cNvPr id="679467628" name=""/>
+          <p:cNvPr id="887385722" name=""/>
           <p:cNvPicPr>
             <a:picLocks noChangeAspect="1"/>
           </p:cNvPicPr>
           <p:nvPr/>
         </p:nvPicPr>
-        <p:blipFill>
+        <p:blipFill rotWithShape="1">
           <a:blip r:embed="rId3"/>
           <a:stretch/>
         </p:blipFill>
@@ -7301,14 +7991,14 @@
       </p:pic>
       <p:sp>
         <p:nvSpPr>
-          <p:cNvPr id="35942662" name=""/>
+          <p:cNvPr id="351566072" name=""/>
           <p:cNvSpPr/>
           <p:nvPr/>
         </p:nvSpPr>
         <p:spPr bwMode="auto">
           <a:xfrm flipH="0" flipV="0">
-            <a:off x="760631" y="1436819"/>
-            <a:ext cx="11241309" cy="3388973"/>
+            <a:off x="760630" y="1436818"/>
+            <a:ext cx="11267948" cy="4120493"/>
           </a:xfrm>
         </p:spPr>
         <p:txBody>
@@ -7544,6 +8234,52 @@
                 <a:cs typeface="Source Sans Pro"/>
               </a:rPr>
               <a:t> bon compromis efficacité/légèreté → à valider sur un corpus plus large</a:t>
+            </a:r>
+            <a:endParaRPr lang="fr-FR" sz="2400" b="0" i="0" u="none" strike="noStrike" cap="none" spc="0">
+              <a:solidFill>
+                <a:schemeClr val="tx1"/>
+              </a:solidFill>
+              <a:latin typeface="Source Sans Pro"/>
+              <a:ea typeface="Source Sans Pro"/>
+              <a:cs typeface="Source Sans Pro"/>
+            </a:endParaRPr>
+          </a:p>
+          <a:p>
+            <a:pPr marL="349965" indent="-349965">
+              <a:lnSpc>
+                <a:spcPct val="100000"/>
+              </a:lnSpc>
+              <a:buFont typeface="Arial"/>
+              <a:buChar char="•"/>
+              <a:defRPr/>
+            </a:pPr>
+            <a:endParaRPr sz="2400">
+              <a:solidFill>
+                <a:schemeClr val="tx1"/>
+              </a:solidFill>
+              <a:latin typeface="Source Sans Pro"/>
+              <a:cs typeface="Source Sans Pro"/>
+            </a:endParaRPr>
+          </a:p>
+          <a:p>
+            <a:pPr marL="349965" indent="-349965">
+              <a:lnSpc>
+                <a:spcPct val="100000"/>
+              </a:lnSpc>
+              <a:buFont typeface="Arial"/>
+              <a:buChar char="•"/>
+              <a:defRPr/>
+            </a:pPr>
+            <a:r>
+              <a:rPr lang="fr-FR" sz="2400" b="0" i="0" u="none" strike="noStrike" cap="none" spc="0">
+                <a:solidFill>
+                  <a:schemeClr val="tx1"/>
+                </a:solidFill>
+                <a:latin typeface="Source Sans Pro"/>
+                <a:ea typeface="Source Sans Pro"/>
+                <a:cs typeface="Source Sans Pro"/>
+              </a:rPr>
+              <a:t>Sentences transformers sont difficiles à expliquer</a:t>
             </a:r>
             <a:endParaRPr sz="2400">
               <a:solidFill>
@@ -7590,7 +8326,7 @@
       </p:grpSpPr>
       <p:sp>
         <p:nvSpPr>
-          <p:cNvPr id="1144574926" name="Title 1"/>
+          <p:cNvPr id="1669404966" name="Title 1"/>
           <p:cNvSpPr>
             <a:spLocks noGrp="1"/>
           </p:cNvSpPr>
@@ -7622,7 +8358,7 @@
       </p:sp>
       <p:sp>
         <p:nvSpPr>
-          <p:cNvPr id="1119915134" name="Espace réservé du numéro de diapositive 5"/>
+          <p:cNvPr id="1701583406" name="Espace réservé du numéro de diapositive 5"/>
           <p:cNvSpPr>
             <a:spLocks noGrp="1"/>
           </p:cNvSpPr>
@@ -7720,13 +8456,13 @@
       </p:sp>
       <p:pic>
         <p:nvPicPr>
-          <p:cNvPr id="439449187" name=""/>
+          <p:cNvPr id="2023147634" name=""/>
           <p:cNvPicPr>
             <a:picLocks noChangeAspect="1"/>
           </p:cNvPicPr>
           <p:nvPr/>
         </p:nvPicPr>
-        <p:blipFill>
+        <p:blipFill rotWithShape="1">
           <a:blip r:embed="rId3"/>
           <a:stretch/>
         </p:blipFill>
@@ -7775,7 +8511,7 @@
       </p:grpSpPr>
       <p:sp>
         <p:nvSpPr>
-          <p:cNvPr id="277466964" name="Title 1"/>
+          <p:cNvPr id="1988836240" name="Title 1"/>
           <p:cNvSpPr>
             <a:spLocks noGrp="1"/>
           </p:cNvSpPr>
@@ -7807,7 +8543,7 @@
       </p:sp>
       <p:sp>
         <p:nvSpPr>
-          <p:cNvPr id="1364511605" name="Content Placeholder 2"/>
+          <p:cNvPr id="150361403" name="Content Placeholder 2"/>
           <p:cNvSpPr>
             <a:spLocks noGrp="1"/>
           </p:cNvSpPr>
@@ -7849,7 +8585,7 @@
                 <a:ea typeface="Source Sans Pro"/>
                 <a:cs typeface="Source Sans Pro"/>
               </a:rPr>
-              <a:t>L’entreprise place de marché propose des crédits à la consommation </a:t>
+              <a:t>L’entreprise prêt à dépenser propose des crédits à la consommation </a:t>
             </a:r>
             <a:r>
               <a:rPr lang="fr-FR" sz="1700" b="0" i="0" u="none" strike="noStrike" cap="none" spc="0">
@@ -8018,7 +8754,7 @@
       </p:sp>
       <p:sp>
         <p:nvSpPr>
-          <p:cNvPr id="569460224" name="Espace réservé du numéro de diapositive 5"/>
+          <p:cNvPr id="406096931" name="Espace réservé du numéro de diapositive 5"/>
           <p:cNvSpPr>
             <a:spLocks noGrp="1"/>
           </p:cNvSpPr>
@@ -8116,13 +8852,13 @@
       </p:sp>
       <p:pic>
         <p:nvPicPr>
-          <p:cNvPr id="1851999578" name=""/>
+          <p:cNvPr id="1566371854" name=""/>
           <p:cNvPicPr>
             <a:picLocks noChangeAspect="1"/>
           </p:cNvPicPr>
           <p:nvPr/>
         </p:nvPicPr>
-        <p:blipFill>
+        <p:blipFill rotWithShape="1">
           <a:blip r:embed="rId3"/>
           <a:srcRect l="45669" t="0" r="0" b="0"/>
           <a:stretch/>
@@ -8152,7 +8888,7 @@
   </mc:AlternateContent>
   <p:timing>
     <p:bldLst>
-      <p:bldP spid="1364511605" grpId="0" uiExpand="1" build="p"/>
+      <p:bldP spid="150361403" grpId="0" uiExpand="1" build="p"/>
     </p:bldLst>
   </p:timing>
 </p:sld>
@@ -8177,7 +8913,7 @@
       </p:grpSpPr>
       <p:sp>
         <p:nvSpPr>
-          <p:cNvPr id="1431938974" name="Title 1"/>
+          <p:cNvPr id="786470364" name="Title 1"/>
           <p:cNvSpPr>
             <a:spLocks noGrp="1"/>
           </p:cNvSpPr>
@@ -8214,7 +8950,7 @@
                 <a:ea typeface="Orkney Medium"/>
                 <a:cs typeface="Orkney Medium"/>
               </a:rPr>
-              <a:t>Présentation et démonstration du tableau de bord</a:t>
+              <a:t>Présentation technique de l’application</a:t>
             </a:r>
             <a:endParaRPr lang="fr-FR"/>
           </a:p>
@@ -8222,7 +8958,7 @@
       </p:sp>
       <p:sp>
         <p:nvSpPr>
-          <p:cNvPr id="606528177" name="Espace réservé du numéro de diapositive 5"/>
+          <p:cNvPr id="731181660" name="Espace réservé du numéro de diapositive 5"/>
           <p:cNvSpPr>
             <a:spLocks noGrp="1"/>
           </p:cNvSpPr>
@@ -8320,13 +9056,13 @@
       </p:sp>
       <p:pic>
         <p:nvPicPr>
-          <p:cNvPr id="1964965532" name=""/>
+          <p:cNvPr id="428782488" name=""/>
           <p:cNvPicPr>
             <a:picLocks noChangeAspect="1"/>
           </p:cNvPicPr>
           <p:nvPr/>
         </p:nvPicPr>
-        <p:blipFill>
+        <p:blipFill rotWithShape="1">
           <a:blip r:embed="rId3"/>
           <a:srcRect l="45669" t="0" r="0" b="0"/>
           <a:stretch/>
@@ -8384,7 +9120,7 @@
       </p:grpSpPr>
       <p:sp>
         <p:nvSpPr>
-          <p:cNvPr id="1618060673" name="Title 1"/>
+          <p:cNvPr id="962235971" name="Title 1"/>
           <p:cNvSpPr>
             <a:spLocks noGrp="1"/>
           </p:cNvSpPr>
@@ -8426,7 +9162,7 @@
                 <a:ea typeface="Orkney Medium"/>
                 <a:cs typeface="Orkney Medium"/>
               </a:rPr>
-              <a:t>Présentation et démonstration du tableau de bord</a:t>
+              <a:t>Présentation technique de l’application</a:t>
             </a:r>
             <a:endParaRPr sz="3600"/>
           </a:p>
@@ -8434,7 +9170,7 @@
       </p:sp>
       <p:sp>
         <p:nvSpPr>
-          <p:cNvPr id="757138122" name="Espace réservé du numéro de diapositive 5"/>
+          <p:cNvPr id="803615379" name="Espace réservé du numéro de diapositive 5"/>
           <p:cNvSpPr>
             <a:spLocks noGrp="1"/>
           </p:cNvSpPr>
@@ -8532,13 +9268,13 @@
       </p:sp>
       <p:pic>
         <p:nvPicPr>
-          <p:cNvPr id="2135574819" name=""/>
+          <p:cNvPr id="1159301405" name=""/>
           <p:cNvPicPr>
             <a:picLocks noChangeAspect="1"/>
           </p:cNvPicPr>
           <p:nvPr/>
         </p:nvPicPr>
-        <p:blipFill>
+        <p:blipFill rotWithShape="1">
           <a:blip r:embed="rId3"/>
           <a:srcRect l="45669" t="0" r="0" b="0"/>
           <a:stretch/>
@@ -8563,7 +9299,7 @@
       </p:pic>
       <p:graphicFrame>
         <p:nvGraphicFramePr>
-          <p:cNvPr id="1446066120" name=""/>
+          <p:cNvPr id="618579550" name=""/>
           <p:cNvGraphicFramePr>
             <a:graphicFrameLocks xmlns:a="http://schemas.openxmlformats.org/drawingml/2006/main" noChangeAspect="1"/>
           </p:cNvGraphicFramePr>
@@ -8579,11 +9315,11 @@
               <p:embed/>
               <p:pic>
                 <p:nvPicPr>
-                  <p:cNvPr id="1446066120" name=""/>
+                  <p:cNvPr id="618579550" name=""/>
                   <p:cNvPicPr/>
                   <p:nvPr/>
                 </p:nvPicPr>
-                <p:blipFill>
+                <p:blipFill rotWithShape="1">
                   <a:blip r:embed="rId4"/>
                   <a:stretch/>
                 </p:blipFill>
@@ -8637,7 +9373,7 @@
       </p:grpSpPr>
       <p:sp>
         <p:nvSpPr>
-          <p:cNvPr id="653208911" name="Title 1"/>
+          <p:cNvPr id="426269826" name="Title 1"/>
           <p:cNvSpPr>
             <a:spLocks noGrp="1"/>
           </p:cNvSpPr>
@@ -8663,7 +9399,7 @@
             </a:pPr>
             <a:r>
               <a:rPr lang="fr-FR"/>
-              <a:t>3 Présentation du dashboard</a:t>
+              <a:t>3 Démonstration de l’application</a:t>
             </a:r>
             <a:endParaRPr lang="fr-FR"/>
           </a:p>
@@ -8671,7 +9407,7 @@
       </p:sp>
       <p:sp>
         <p:nvSpPr>
-          <p:cNvPr id="1408559813" name="Espace réservé du numéro de diapositive 5"/>
+          <p:cNvPr id="1960544491" name="Espace réservé du numéro de diapositive 5"/>
           <p:cNvSpPr>
             <a:spLocks noGrp="1"/>
           </p:cNvSpPr>
@@ -8769,13 +9505,13 @@
       </p:sp>
       <p:pic>
         <p:nvPicPr>
-          <p:cNvPr id="1476788350" name=""/>
+          <p:cNvPr id="2048870549" name=""/>
           <p:cNvPicPr>
             <a:picLocks noChangeAspect="1"/>
           </p:cNvPicPr>
           <p:nvPr/>
         </p:nvPicPr>
-        <p:blipFill>
+        <p:blipFill rotWithShape="1">
           <a:blip r:embed="rId3"/>
           <a:srcRect l="45669" t="0" r="0" b="0"/>
           <a:stretch/>
@@ -8833,7 +9569,7 @@
       </p:grpSpPr>
       <p:sp>
         <p:nvSpPr>
-          <p:cNvPr id="1577555805" name="Espace réservé du numéro de diapositive 5"/>
+          <p:cNvPr id="1862675069" name="Espace réservé du numéro de diapositive 5"/>
           <p:cNvSpPr>
             <a:spLocks noGrp="1"/>
           </p:cNvSpPr>
@@ -8931,13 +9667,13 @@
       </p:sp>
       <p:pic>
         <p:nvPicPr>
-          <p:cNvPr id="796092632" name=""/>
+          <p:cNvPr id="858431209" name=""/>
           <p:cNvPicPr>
             <a:picLocks noChangeAspect="1"/>
           </p:cNvPicPr>
           <p:nvPr/>
         </p:nvPicPr>
-        <p:blipFill>
+        <p:blipFill rotWithShape="1">
           <a:blip r:embed="rId3"/>
           <a:srcRect l="45669" t="0" r="0" b="0"/>
           <a:stretch/>
@@ -8962,7 +9698,7 @@
       </p:pic>
       <p:sp>
         <p:nvSpPr>
-          <p:cNvPr id="1682113448" name="Title 1"/>
+          <p:cNvPr id="1694453321" name="Title 1"/>
           <p:cNvSpPr>
             <a:spLocks noGrp="1"/>
           </p:cNvSpPr>
@@ -8999,7 +9735,7 @@
             </a:r>
             <a:r>
               <a:rPr sz="3600"/>
-              <a:t>Présentation du dashboard</a:t>
+              <a:t>Démonstration de l’application</a:t>
             </a:r>
             <a:endParaRPr sz="3600"/>
           </a:p>
@@ -9007,7 +9743,7 @@
       </p:sp>
       <p:sp>
         <p:nvSpPr>
-          <p:cNvPr id="539737827" name=""/>
+          <p:cNvPr id="1496168390" name=""/>
           <p:cNvSpPr txBox="1"/>
           <p:nvPr/>
         </p:nvSpPr>
@@ -9083,7 +9819,7 @@
       </p:grpSpPr>
       <p:sp>
         <p:nvSpPr>
-          <p:cNvPr id="1498273356" name="Title 1"/>
+          <p:cNvPr id="1895833492" name="Title 1"/>
           <p:cNvSpPr>
             <a:spLocks noGrp="1"/>
           </p:cNvSpPr>
@@ -9117,7 +9853,7 @@
       </p:sp>
       <p:sp>
         <p:nvSpPr>
-          <p:cNvPr id="626692126" name="Espace réservé du numéro de diapositive 5"/>
+          <p:cNvPr id="1380484331" name="Espace réservé du numéro de diapositive 5"/>
           <p:cNvSpPr>
             <a:spLocks noGrp="1"/>
           </p:cNvSpPr>
@@ -9215,13 +9951,13 @@
       </p:sp>
       <p:pic>
         <p:nvPicPr>
-          <p:cNvPr id="37646443" name=""/>
+          <p:cNvPr id="1528509879" name=""/>
           <p:cNvPicPr>
             <a:picLocks noChangeAspect="1"/>
           </p:cNvPicPr>
           <p:nvPr/>
         </p:nvPicPr>
-        <p:blipFill>
+        <p:blipFill rotWithShape="1">
           <a:blip r:embed="rId3"/>
           <a:srcRect l="45669" t="0" r="0" b="0"/>
           <a:stretch/>

</xml_diff>